<commit_message>
Refresh offline docs, article PDF and presentation with verified notification evidence
</commit_message>
<xml_diff>
--- a/docs/presentation/demo.pptx
+++ b/docs/presentation/demo.pptx
@@ -2,26 +2,26 @@
 <file path=ppt/presentation.xml><?xml version="1.0" encoding="utf-8"?>
 <p:presentation xmlns:p="http://schemas.openxmlformats.org/presentationml/2006/main">
   <p:sldMasterIdLst>
-    <p:sldMasterId xmlns:r="http://schemas.openxmlformats.org/officeDocument/2006/relationships" id="2147483648" r:id="R23740ec4743a4c33"/>
+    <p:sldMasterId xmlns:r="http://schemas.openxmlformats.org/officeDocument/2006/relationships" id="2147483648" r:id="R5fa2fd771d7041d6"/>
   </p:sldMasterIdLst>
   <p:notesMasterIdLst>
-    <p:notesMasterId xmlns:r="http://schemas.openxmlformats.org/officeDocument/2006/relationships" r:id="Rf81bfc78012c45ee"/>
+    <p:notesMasterId xmlns:r="http://schemas.openxmlformats.org/officeDocument/2006/relationships" r:id="Rd097efc784324053"/>
   </p:notesMasterIdLst>
   <p:sldIdLst>
-    <p:sldId xmlns:r="http://schemas.openxmlformats.org/officeDocument/2006/relationships" id="256" r:id="Re77aa6f538284835"/>
-    <p:sldId xmlns:r="http://schemas.openxmlformats.org/officeDocument/2006/relationships" id="257" r:id="R382d1600cd8a45c8"/>
-    <p:sldId xmlns:r="http://schemas.openxmlformats.org/officeDocument/2006/relationships" id="258" r:id="R6778a0835ae447ed"/>
-    <p:sldId xmlns:r="http://schemas.openxmlformats.org/officeDocument/2006/relationships" id="259" r:id="R4447dacfe1b84c31"/>
-    <p:sldId xmlns:r="http://schemas.openxmlformats.org/officeDocument/2006/relationships" id="260" r:id="R9db430bddd6946fd"/>
-    <p:sldId xmlns:r="http://schemas.openxmlformats.org/officeDocument/2006/relationships" id="261" r:id="R5f9a9eb22cc3463a"/>
-    <p:sldId xmlns:r="http://schemas.openxmlformats.org/officeDocument/2006/relationships" id="262" r:id="R70b03ed3b385429b"/>
-    <p:sldId xmlns:r="http://schemas.openxmlformats.org/officeDocument/2006/relationships" id="263" r:id="R01678a81da89421f"/>
-    <p:sldId xmlns:r="http://schemas.openxmlformats.org/officeDocument/2006/relationships" id="264" r:id="R7f4d7e2a6364440f"/>
-    <p:sldId xmlns:r="http://schemas.openxmlformats.org/officeDocument/2006/relationships" id="265" r:id="R7d8693325a914d2d"/>
-    <p:sldId xmlns:r="http://schemas.openxmlformats.org/officeDocument/2006/relationships" id="266" r:id="Ra825c436e7df4176"/>
-    <p:sldId xmlns:r="http://schemas.openxmlformats.org/officeDocument/2006/relationships" id="267" r:id="R284de7a088d3419b"/>
-    <p:sldId xmlns:r="http://schemas.openxmlformats.org/officeDocument/2006/relationships" id="268" r:id="R259fe8be341c49fd"/>
-    <p:sldId xmlns:r="http://schemas.openxmlformats.org/officeDocument/2006/relationships" id="269" r:id="R3485d4ddb04e458a"/>
+    <p:sldId xmlns:r="http://schemas.openxmlformats.org/officeDocument/2006/relationships" id="256" r:id="R09335de2aa57410b"/>
+    <p:sldId xmlns:r="http://schemas.openxmlformats.org/officeDocument/2006/relationships" id="257" r:id="Rf1830bfe981e4533"/>
+    <p:sldId xmlns:r="http://schemas.openxmlformats.org/officeDocument/2006/relationships" id="258" r:id="R631ef246af034d15"/>
+    <p:sldId xmlns:r="http://schemas.openxmlformats.org/officeDocument/2006/relationships" id="259" r:id="R57319380cf724fb2"/>
+    <p:sldId xmlns:r="http://schemas.openxmlformats.org/officeDocument/2006/relationships" id="260" r:id="Rc380f84697904860"/>
+    <p:sldId xmlns:r="http://schemas.openxmlformats.org/officeDocument/2006/relationships" id="261" r:id="R22acc2f159cf4e8d"/>
+    <p:sldId xmlns:r="http://schemas.openxmlformats.org/officeDocument/2006/relationships" id="262" r:id="R4c051ca830e94d56"/>
+    <p:sldId xmlns:r="http://schemas.openxmlformats.org/officeDocument/2006/relationships" id="263" r:id="R9ba3b36b28064beb"/>
+    <p:sldId xmlns:r="http://schemas.openxmlformats.org/officeDocument/2006/relationships" id="264" r:id="Ra29e443f943a41c2"/>
+    <p:sldId xmlns:r="http://schemas.openxmlformats.org/officeDocument/2006/relationships" id="265" r:id="R0a9c5cacbc614e3b"/>
+    <p:sldId xmlns:r="http://schemas.openxmlformats.org/officeDocument/2006/relationships" id="266" r:id="R833f7682b0f34b61"/>
+    <p:sldId xmlns:r="http://schemas.openxmlformats.org/officeDocument/2006/relationships" id="267" r:id="R40bb4e2fdbe04864"/>
+    <p:sldId xmlns:r="http://schemas.openxmlformats.org/officeDocument/2006/relationships" id="268" r:id="R596ba298393d48d5"/>
+    <p:sldId xmlns:r="http://schemas.openxmlformats.org/officeDocument/2006/relationships" id="269" r:id="Rf3e4da4f48064cf7"/>
   </p:sldIdLst>
   <p:sldSz cx="12192000" cy="6858000"/>
   <p:notesSz cx="6858000" cy="9144000"/>
@@ -585,7 +585,7 @@
           </a:p>
           <a:p xmlns:a="http://schemas.openxmlformats.org/drawingml/2006/main">
             <a:r>
-              <a:t>Sources: docs/reference/protocol.md, Operation commitment; transaction-security-module/src/main/java/com/demo/securityapp/Processor.java, businessRejection, register; docs/history/article-review-2026-09-05.md, R09–R10.</a:t>
+              <a:t>Sources: docs/reference/protocol.md, Operation commitment; transaction-security-module/src/main/java/com/demo/securityapp/service/Processor.java, businessRejection, register; docs/history/article-review-2026-09-05.md, R09–R10.</a:t>
             </a:r>
           </a:p>
         </p:txBody>
@@ -655,6 +655,61 @@
           <a:lstStyle xmlns:a="http://schemas.openxmlformats.org/drawingml/2006/main"/>
           <a:p xmlns:a="http://schemas.openxmlformats.org/drawingml/2006/main">
             <a:r>
+              <a:t>Timing: about 1.5 minutes, with historical recovery detail available for questions.</a:t>
+            </a:r>
+          </a:p>
+          <a:p xmlns:a="http://schemas.openxmlformats.org/drawingml/2006/main">
+            <a:r>
+              <a:t>An INTEGRITY_INCIDENT causes the processor to append protected audit evidence and insert the first notification_outbox row for that operation in one Audit/Protected SQL transaction. A failure of either insert rolls back both. Separate runtime grants permit audit insertion and delivery-state updates while denying key and accounting roles the ability to enqueue notifications.</a:t>
+            </a:r>
+          </a:p>
+          <a:p xmlns:a="http://schemas.openxmlformats.org/drawingml/2006/main">
+            <a:r>
+              <a:t>A dedicated scheduler claims pending notifications with a lease, attempts email delivery and stores acceptance or a retry marker. It does not contact SMTP while checking or settling a transfer. SMTP outage cannot authorize invalid content and does not gate financial processing. Failure to persist protected audit evidence remains a separate storage failure.</a:t>
+            </a:r>
+          </a:p>
+          <a:p xmlns:a="http://schemas.openxmlformats.org/drawingml/2006/main">
+            <a:r>
+              <a:t>Messages contain an incident reference, operation UUID, audit sequence, observation time and an allowlisted reason. Arbitrary incident detail remains in protected audit evidence. The sender uses a configured recipient list through BCC, a fixed subject, plain text and a stable message identifier. It excludes accounts, amounts, source payloads and credentials.</a:t>
+            </a:r>
+          </a:p>
+          <a:p xmlns:a="http://schemas.openxmlformats.org/drawingml/2006/main">
+            <a:r>
+              <a:t>Normal startup uses loopback-only Mailpit to capture messages locally. This is not Gmail delivery. Real SMTP requires explicit authentication, TLS and an authorized sender and recipients. The private test recipient and SMTP secrets stay outside the repository and distribution package.</a:t>
+            </a:r>
+          </a:p>
+          <a:p xmlns:a="http://schemas.openxmlformats.org/drawingml/2006/main">
+            <a:r>
+              <a:t>Repeated observations of one operation preserve later audit history but do not create another initial notification. SMTP delivery remains at least once. A crash between provider acceptance and the protected delivery update can cause a duplicate with the same Event ID. A successful SMTP response alone does not prove inbox delivery or human review.</a:t>
+            </a:r>
+          </a:p>
+          <a:p xmlns:a="http://schemas.openxmlformats.org/drawingml/2006/main">
+            <a:r>
+              <a:t>The September 8 PostgreSQL-to-Mailpit run observed four cases: a valid operation with no alert, a fabricated row with quarantine and one alert, repeated observation with the same notification, and post-settlement tampering with one alert and the original completed outcome unchanged. The repeated case covers five seconds of normal delivery, not an exactly-once guarantee.</a:t>
+            </a:r>
+          </a:p>
+          <a:p xmlns:a="http://schemas.openxmlformats.org/drawingml/2006/main">
+            <a:r>
+              <a:t>A discrepancy is not proof of fraud or identity. An alert detected after settlement does not mean that the original authenticated operation never settled. The operator must review the trusted outcome and evidence.</a:t>
+            </a:r>
+          </a:p>
+          <a:p xmlns:a="http://schemas.openxmlformats.org/drawingml/2006/main">
+            <a:r>
+              <a:t>Notification sources: docs/reference/notifications.md; docs/evidence/notification-verification-2026-09-08.json; transaction-security-module/src/main/java/com/demo/securityapp/audit/AuditLog.java; transaction-security-module/src/main/java/com/demo/securityapp/notification/NotificationDispatcher.java; transaction-security-module/src/main/java/com/demo/securityapp/notification/NotificationOutbox.java; transaction-security-module/src/main/java/com/demo/securityapp/notification/SmtpNotificationSender.java.</a:t>
+            </a:r>
+          </a:p>
+          <a:p xmlns:a="http://schemas.openxmlformats.org/drawingml/2006/main">
+            <a:r>
+              <a:t/>
+            </a:r>
+          </a:p>
+          <a:p xmlns:a="http://schemas.openxmlformats.org/drawingml/2006/main">
+            <a:r>
+              <a:t>Historical recovery evidence, September 6, 2026. Two local JVM outage cases passed. These are separate from the September 8 notification run:</a:t>
+            </a:r>
+          </a:p>
+          <a:p xmlns:a="http://schemas.openxmlformats.org/drawingml/2006/main">
+            <a:r>
               <a:t>Timing: 1.5 minutes.</a:t>
             </a:r>
           </a:p>
@@ -755,47 +810,42 @@
           <a:lstStyle xmlns:a="http://schemas.openxmlformats.org/drawingml/2006/main"/>
           <a:p xmlns:a="http://schemas.openxmlformats.org/drawingml/2006/main">
             <a:r>
-              <a:t>Timing: 1.5 minutes.</a:t>
-            </a:r>
-          </a:p>
-          <a:p xmlns:a="http://schemas.openxmlformats.org/drawingml/2006/main">
-            <a:r>
-              <a:t>These results are from September 6, 2026, with two PostgreSQL databases and embedded ActiveMQ. A later worker-admission failure-path review added two regression tests; the recorded load run contained 83 Java tests. The test used one Windows machine with an Intel Core i7-13620H, 16 logical CPUs, about 16 GB of memory, Docker PostgreSQL and software keys. No cloud KMS or real payment network was in the critical path.</a:t>
-            </a:r>
-          </a:p>
-          <a:p xmlns:a="http://schemas.openxmlformats.org/drawingml/2006/main">
-            <a:r>
-              <a:t>The generator offered exactly 20 transfers per second for 120 seconds across eight test accounts. All 2,400 unique operations completed with zero failures. Completion includes the protected result, exact paired postings, matching operation content and a relayed durable audit outcome. Balance checks passed.</a:t>
-            </a:r>
-          </a:p>
-          <a:p xmlns:a="http://schemas.openxmlformats.org/drawingml/2006/main">
-            <a:r>
-              <a:t>The 20.3091 TPS figure counts completions in the window after the first ten seconds of warmup, from second 10 through second 120. A finite completion window can differ slightly from the constant arrival rate because of its boundaries. Acceptance used zero configured throughput tolerance.</a:t>
-            </a:r>
-          </a:p>
-          <a:p xmlns:a="http://schemas.openxmlformats.org/drawingml/2006/main">
-            <a:r>
-              <a:t>The 19.9371 TPS figure includes the entire run with warmup and final drain. Drain is the time required to finish remaining work after arrivals stop. It was approximately 378 ms. Reporting both prevents a steady-window result from being mistaken for whole-run wall-clock throughput.</a:t>
-            </a:r>
-          </a:p>
-          <a:p xmlns:a="http://schemas.openxmlformats.org/drawingml/2006/main">
-            <a:r>
-              <a:t>A p95 of 3989.839 ms means that approximately 95% of measured end-to-end completion latencies were at or below that value. It is not single-HMAC latency or peak database capacity.</a:t>
-            </a:r>
-          </a:p>
-          <a:p xmlns:a="http://schemas.openxmlformats.org/drawingml/2006/main">
-            <a:r>
-              <a:t>The standard Maven verify run passed 83 Java tests with no failures, errors or skips. Separately, 15 functional/adversarial PostgreSQL scenarios and two real JVM outage cases passed. These categories are reported separately.</a:t>
-            </a:r>
-          </a:p>
-          <a:p xmlns:a="http://schemas.openxmlformats.org/drawingml/2006/main">
-            <a:r>
-              <a:t>The experiment did not measure maximum capacity, comparative cost, a ten-minute soak or a million records. It supports the stated local workload rather than a production SLA.</a:t>
-            </a:r>
-          </a:p>
-          <a:p xmlns:a="http://schemas.openxmlformats.org/drawingml/2006/main">
-            <a:r>
-              <a:t>Sources: docs/evidence/local-verification-2026-09-06.json, javaTests, scenarios, load; docs/evidence/local-recovery-2026-09-06.json; docs/reference/implementation-status.md.</a:t>
+              <a:t>Timing: about 1.5 minutes.</a:t>
+            </a:r>
+          </a:p>
+          <a:p xmlns:a="http://schemas.openxmlformats.org/drawingml/2006/main">
+            <a:r>
+              <a:t>The most recent full load run is September 7, 2026, before incident email support. It offered 20 transfers per second for 120 seconds. All 2,400 operations completed with zero operation failures, and protected accounting and durable audit checks passed. The steady completion window measured 19.963636363636365 TPS. The strict throughput requirement was at least 20 TPS with zero tolerance. Therefore the load and combined acceptance result FAILED. Do not round this measurement to 20 TPS or describe the acceptance result as a pass.</a:t>
+            </a:r>
+          </a:p>
+          <a:p xmlns:a="http://schemas.openxmlformats.org/drawingml/2006/main">
+            <a:r>
+              <a:t>The September 7 run passed 92 Java tests in 14 suites and 15 PostgreSQL scenarios. Its whole-run rate was 19.940251926438954 TPS. End-to-end latency p95 was 668.2416 ms and p99 was 791.458 ms, shown rounded to 668 and 791 ms on the slide. These are completion latencies, not HMAC timings or peak database capacity.</a:t>
+            </a:r>
+          </a:p>
+          <a:p xmlns:a="http://schemas.openxmlformats.org/drawingml/2006/main">
+            <a:r>
+              <a:t>The historical initial September 6 run used 83 Java tests and passed its steady-window load gate at 20.3091 TPS. Its whole-run rate was 19.9371 TPS, with roughly 378 ms final drain and p95 3989.839 ms. A later worker-admission failure-path review added three regression tests. The separate final September 6 run passed 86 Java tests, 15 PostgreSQL scenarios and a load gate at exactly 20.0000 steady TPS. Its whole-run rate was 19.9173 TPS. These earlier passes remain historical evidence and do not supersede September 7's failed gate.</a:t>
+            </a:r>
+          </a:p>
+          <a:p xmlns:a="http://schemas.openxmlformats.org/drawingml/2006/main">
+            <a:r>
+              <a:t>The September 8 notification implementation passed 137 Java tests in 19 suites, with zero failures, errors or skips. It also passed 44 Node checks, 18 live PostgreSQL role-isolation checks and the four local PostgreSQL-to-Mailpit cases. Those figures describe the pre-publication notification stage. Subsequent documentation/publication regressions are separate checks. No new load benchmark or production SMTP delivery occurred in this stage.</a:t>
+            </a:r>
+          </a:p>
+          <a:p xmlns:a="http://schemas.openxmlformats.org/drawingml/2006/main">
+            <a:r>
+              <a:t>The load environment was one Windows machine with an Intel Core i7-13620H, 16 logical CPUs, approximately 16 GB RAM, two Docker PostgreSQL databases, embedded ActiveMQ and software keys. Neither a real payment network nor cloud KMS participated.</a:t>
+            </a:r>
+          </a:p>
+          <a:p xmlns:a="http://schemas.openxmlformats.org/drawingml/2006/main">
+            <a:r>
+              <a:t>The experiment does not establish maximum capacity, comparative cost, email capacity, a long soak, a million-record audit or a production SLA. Keep failed and successful reports with their dates, code context and exact acceptance criteria.</a:t>
+            </a:r>
+          </a:p>
+          <a:p xmlns:a="http://schemas.openxmlformats.org/drawingml/2006/main">
+            <a:r>
+              <a:t>Sources: docs/evidence/local-verification-2026-09-07.json; docs/evidence/local-verification-2026-09-06.json; docs/evidence/local-verification-2026-09-06-final.json; docs/evidence/notification-verification-2026-09-08.json; docs/reference/notifications.md; README.md.</a:t>
             </a:r>
           </a:p>
         </p:txBody>
@@ -985,12 +1035,12 @@
           </a:p>
           <a:p xmlns:a="http://schemas.openxmlformats.org/drawingml/2006/main">
             <a:r>
-              <a:t>A short demonstration can show a normal transfer and identical-key retry, a fabricated primary row, and a change after verification. Show the protected result and postings, not just an HTTP response. For a reliable presentation, retained reports can serve as recorded evidence without presenting them as a newly executed live run.</a:t>
-            </a:r>
-          </a:p>
-          <a:p xmlns:a="http://schemas.openxmlformats.org/drawingml/2006/main">
-            <a:r>
-              <a:t>Local commands are documented in docs/reference/running.md. verify-local.ps1 runs tests, scenarios and load. recovery.ps1 really stops services and must run separately, without a concurrent demonstration. It should not start unexpectedly during a customer meeting. Never share .local: it contains secrets and key material. Share the sanitized JSON under docs/evidence and the prepared documents.</a:t>
+              <a:t>A short demonstration can show a normal transfer and identical-key retry, a fabricated primary row with its captured alert, and tampering after settlement with human review of the original protected result. The post-verification pause scenario remains available in the test harness. Show the protected result and postings, not just an HTTP response. For a reliable presentation, retained reports can serve as recorded evidence without presenting them as a newly executed live run.</a:t>
+            </a:r>
+          </a:p>
+          <a:p xmlns:a="http://schemas.openxmlformats.org/drawingml/2006/main">
+            <a:r>
+              <a:t>Local commands are documented in docs/reference/running.md. verify-local.ps1 runs tests, scenarios and load. recovery.ps1 really stops services and must run separately, without a concurrent demonstration. It should not start unexpectedly during a customer meeting. Never share .local: it contains secrets and key material. Share the sanitized JSON under docs/evidence and the prepared documents. Notification evidence is a local Mailpit capture. Do not claim public email delivery or a new load benchmark.</a:t>
             </a:r>
           </a:p>
           <a:p xmlns:a="http://schemas.openxmlformats.org/drawingml/2006/main">
@@ -1000,7 +1050,17 @@
           </a:p>
           <a:p xmlns:a="http://schemas.openxmlformats.org/drawingml/2006/main">
             <a:r>
-              <a:t>Sources: docs/reference/architecture.md; docs/reference/running.md; docs/reference/implementation-status.md; scripts/scenarios.mjs.</a:t>
+              <a:t>Sources: docs/reference/architecture.md; docs/reference/running.md; docs/reference/implementation-status.md; scripts/scenarios.mjs; docs/reference/notifications.md; docs/evidence/notification-verification-2026-09-08.json.</a:t>
+            </a:r>
+          </a:p>
+          <a:p xmlns:a="http://schemas.openxmlformats.org/drawingml/2006/main">
+            <a:r>
+              <a:t>Implementation snapshot: https://github.com/ViktorKhudiaiev/demo_security_module/tree/e2e35de02abefdcee92f99be58381e53dfb62201</a:t>
+            </a:r>
+          </a:p>
+          <a:p xmlns:a="http://schemas.openxmlformats.org/drawingml/2006/main">
+            <a:r>
+              <a:t>Article and evidence snapshot: https://github.com/ViktorKhudiaiev/demo_security_module/tree/2dbad6441d3d08a879c976e73613c444d42bd561</a:t>
             </a:r>
           </a:p>
         </p:txBody>
@@ -1095,7 +1155,7 @@
           </a:p>
           <a:p xmlns:a="http://schemas.openxmlformats.org/drawingml/2006/main">
             <a:r>
-              <a:t>The integrating application checks an individual user's right to transfer funds. We deliberately do not build another Identity Provider or require actorId inside this module. However, the application must protect its API and issuance credential. If the trusted application itself requests an improper transfer, a MAC does not understand that business meaning.</a:t>
+              <a:t>The integrating application must check an individual user's right to transfer funds. The local demo enforces shared bearer service credentials, without implementing a human identity or account-entitlement system. We deliberately do not build another Identity Provider or require actorId inside this module. However, the application must protect its API and issuance credential. If the trusted application itself requests an improper transfer, a MAC does not understand that business meaning.</a:t>
             </a:r>
           </a:p>
           <a:p xmlns:a="http://schemas.openxmlformats.org/drawingml/2006/main">
@@ -1190,6 +1250,11 @@
           </a:p>
           <a:p xmlns:a="http://schemas.openxmlformats.org/drawingml/2006/main">
             <a:r>
+              <a:t>The reporting branch adds notification_outbox in the existing Audit/Protected database. On an incident, AuditLog commits both history and the first notification atomically. A separate email dispatcher in the processor JVM handles SMTP retries and a per-dispatcher rate cap. Mailpit runs separately as loopback-only test infrastructure on ports 1025 and 8025. It captures messages locally, without Gmail delivery. A configured authenticated SMTP provider is an optional deployment choice. This reporting path does not gate settlement.</a:t>
+            </a:r>
+          </a:p>
+          <a:p xmlns:a="http://schemas.openxmlformats.org/drawingml/2006/main">
+            <a:r>
               <a:t>The broker buffers identifiers. It is not payment authorization, an independent failover node, or evidence of improved maximum capacity. Duplicate delivery is expected. No global transaction spans both databases and JMS. A Kafka adapter would need distinct offset/partition semantics.</a:t>
             </a:r>
           </a:p>
@@ -1270,7 +1335,7 @@
           </a:p>
           <a:p xmlns:a="http://schemas.openxmlformats.org/drawingml/2006/main">
             <a:r>
-              <a:t>Read from top to bottom. The integrating application has already checked business permission. Its service credential allows a MAC request. The key service validates the schema and commits an independent receipt before returning the response. This ensures that an authentically issued operation has an independent record even before primary publication.</a:t>
+              <a:t>Read from top to bottom. Production integration must check business permission upstream. The local demo models this boundary with shared bearer service credentials, without an individual user-entitlement system. Its service credential allows a MAC request. The key service validates the schema and commits an independent receipt before returning the response. This ensures that an authentically issued operation has an independent record even before primary publication.</a:t>
             </a:r>
           </a:p>
           <a:p xmlns:a="http://schemas.openxmlformats.org/drawingml/2006/main">
@@ -1300,7 +1365,7 @@
           </a:p>
           <a:p xmlns:a="http://schemas.openxmlformats.org/drawingml/2006/main">
             <a:r>
-              <a:t>Sources: tokenization-module/src/main/java/com/demo/keyservice/IssuanceService.java, issue; transaction-security-module/src/main/java/com/demo/securityapp/Processor.java, discover, process, settle, relay; scripts/load-evidence.mjs.</a:t>
+              <a:t>Sources: tokenization-module/src/main/java/com/demo/keyservice/service/IssuanceService.java, issue; transaction-security-module/src/main/java/com/demo/securityapp/service/Processor.java, discover, process, settle, relay; scripts/load-evidence.mjs.</a:t>
             </a:r>
           </a:p>
         </p:txBody>
@@ -1405,7 +1470,7 @@
           </a:p>
           <a:p xmlns:a="http://schemas.openxmlformats.org/drawingml/2006/main">
             <a:r>
-              <a:t>Sources: docs/reference/protocol.md, Operation commitment; tokenization-module/src/main/java/com/demo/integrity/CanonicalEncoder.java; tokenization-module/src/test/java/com/demo/integrity/CanonicalEncoderTest.java.</a:t>
+              <a:t>Sources: docs/reference/protocol.md, Operation commitment; tokenization-module/src/main/java/com/demo/integrity/crypto/CanonicalEncoder.java; tokenization-module/src/test/java/com/demo/integrity/crypto/CanonicalEncoderTest.java.</a:t>
             </a:r>
           </a:p>
         </p:txBody>
@@ -1505,7 +1570,7 @@
           </a:p>
           <a:p xmlns:a="http://schemas.openxmlformats.org/drawingml/2006/main">
             <a:r>
-              <a:t>Sources: docs/reference/protocol.md; tokenization-module/src/main/java/com/demo/keyservice/LocalKeyVault.java; tokenization-module/src/main/java/com/demo/keyservice/ServiceAuthenticationFilter.java; docs/history/article-review-2026-09-05.md, R04–R08.</a:t>
+              <a:t>Sources: docs/reference/protocol.md; tokenization-module/src/main/java/com/demo/keyservice/vault/LocalKeyVault.java; tokenization-module/src/main/java/com/demo/keyservice/security/ServiceAuthenticationFilter.java; docs/history/article-review-2026-09-05.md, R04–R08.</a:t>
             </a:r>
           </a:p>
         </p:txBody>
@@ -1610,7 +1675,7 @@
           </a:p>
           <a:p xmlns:a="http://schemas.openxmlformats.org/drawingml/2006/main">
             <a:r>
-              <a:t>Sources: transaction-security-module/src/main/java/com/demo/securityapp/Processor.java, process and settle; docs/evidence/local-verification-2026-09-06.json, tamper-after-verification-before-use-is-quarantined and delete-after-verification-is-quarantined; docs/history/article-review-2026-09-05.md, R01.</a:t>
+              <a:t>Sources: transaction-security-module/src/main/java/com/demo/securityapp/service/Processor.java, process and settle; docs/evidence/local-verification-2026-09-06.json, tamper-after-verification-before-use-is-quarantined and delete-after-verification-is-quarantined; docs/history/article-review-2026-09-05.md, R01.</a:t>
             </a:r>
           </a:p>
         </p:txBody>
@@ -1695,7 +1760,7 @@
           </a:p>
           <a:p xmlns:a="http://schemas.openxmlformats.org/drawingml/2006/main">
             <a:r>
-              <a:t>The check is periodic. The code allows a five-second publication grace window, and further delay depends on inventory scanning. Issued-but-missing means a discrepancy. Either malicious deletion or an application crash before primary publication can cause it. Intent cannot be inferred automatically.</a:t>
+              <a:t>The check is periodic. The five-second grace threshold is measured from the authenticated Operation.createdAtMicros, not the receipt commit or primary publication. Slow issuance can consume that interval. Further detection delay depends on inventory scanning, so this is not a five-second detection SLA. Issued-but-missing means a discrepancy. Either malicious deletion or an application crash before primary publication can cause it. Intent cannot be inferred automatically.</a:t>
             </a:r>
           </a:p>
           <a:p xmlns:a="http://schemas.openxmlformats.org/drawingml/2006/main">
@@ -1715,7 +1780,7 @@
           </a:p>
           <a:p xmlns:a="http://schemas.openxmlformats.org/drawingml/2006/main">
             <a:r>
-              <a:t>Sources: docs/reference/protocol.md, Issuance and retries, Signed checkpoints; transaction-security-module/src/main/java/com/demo/securityapp/Processor.java, reconcile; transaction-security-module/src/main/java/com/demo/securityapp/AuditLog.java; docs/history/article-review-2026-09-05.md, R03–R04.</a:t>
+              <a:t>Sources: docs/reference/protocol.md, Issuance and retries, Signed checkpoints; transaction-security-module/src/main/java/com/demo/securityapp/service/Processor.java, reconcile; transaction-security-module/src/main/java/com/demo/securityapp/audit/AuditLog.java; docs/history/article-review-2026-09-05.md, R03–R04.</a:t>
             </a:r>
           </a:p>
         </p:txBody>
@@ -1825,7 +1890,7 @@
           </a:p>
           <a:p xmlns:a="http://schemas.openxmlformats.org/drawingml/2006/main">
             <a:r>
-              <a:t>Sources: transaction-security-module/src/main/java/com/demo/securityapp/Processor.java, settle, businessRejection, outcome, relay; docs/reference/protocol.md, Issuance and retries; docs/evidence/local-verification-2026-09-06.json.</a:t>
+              <a:t>Sources: transaction-security-module/src/main/java/com/demo/securityapp/service/Processor.java, settle, businessRejection, outcome, relay; docs/reference/protocol.md, Issuance and retries; docs/evidence/local-verification-2026-09-06.json.</a:t>
             </a:r>
           </a:p>
         </p:txBody>
@@ -1893,7 +1958,7 @@
   </p:cSld>
   <p:clrMap bg1="lt1" tx1="dk1" bg2="lt2" tx2="dk2" accent1="accent1" accent2="accent2" accent3="accent3" accent4="accent4" accent5="accent5" accent6="accent6" hlink="hlink" folHlink="folHlink"/>
   <p:sldLayoutIdLst>
-    <p:sldLayoutId xmlns:r="http://schemas.openxmlformats.org/officeDocument/2006/relationships" id="2147483649" r:id="Rd210531dc0714fdf"/>
+    <p:sldLayoutId xmlns:r="http://schemas.openxmlformats.org/officeDocument/2006/relationships" id="2147483649" r:id="Re6ed1bce107c4ec9"/>
   </p:sldLayoutIdLst>
   <p:txStyles>
     <p:titleStyle>
@@ -2473,6 +2538,7 @@
           <a:lstStyle xmlns:a="http://schemas.openxmlformats.org/drawingml/2006/main"/>
           <a:p xmlns:a="http://schemas.openxmlformats.org/drawingml/2006/main">
             <a:pPr algn="l">
+              <a:buNone/>
               <a:defRPr sz="4950" b="1">
                 <a:solidFill>
                   <a:srgbClr val="142D4E"/>
@@ -2496,6 +2562,7 @@
           </a:p>
           <a:p xmlns:a="http://schemas.openxmlformats.org/drawingml/2006/main">
             <a:pPr algn="l">
+              <a:buNone/>
               <a:defRPr sz="4950" b="1">
                 <a:solidFill>
                   <a:srgbClr val="142D4E"/>
@@ -2553,6 +2620,7 @@
           <a:lstStyle xmlns:a="http://schemas.openxmlformats.org/drawingml/2006/main"/>
           <a:p xmlns:a="http://schemas.openxmlformats.org/drawingml/2006/main">
             <a:pPr algn="l">
+              <a:buNone/>
               <a:defRPr sz="2325" b="0">
                 <a:solidFill>
                   <a:srgbClr val="26364B"/>
@@ -2576,6 +2644,7 @@
           </a:p>
           <a:p xmlns:a="http://schemas.openxmlformats.org/drawingml/2006/main">
             <a:pPr algn="l">
+              <a:buNone/>
               <a:defRPr sz="2325" b="0">
                 <a:solidFill>
                   <a:srgbClr val="26364B"/>
@@ -2633,6 +2702,7 @@
           <a:lstStyle xmlns:a="http://schemas.openxmlformats.org/drawingml/2006/main"/>
           <a:p xmlns:a="http://schemas.openxmlformats.org/drawingml/2006/main">
             <a:pPr algn="l">
+              <a:buNone/>
               <a:defRPr sz="1800" b="0">
                 <a:solidFill>
                   <a:srgbClr val="5E6A78"/>
@@ -2656,6 +2726,7 @@
           </a:p>
           <a:p xmlns:a="http://schemas.openxmlformats.org/drawingml/2006/main">
             <a:pPr algn="l">
+              <a:buNone/>
               <a:defRPr sz="1800" b="0">
                 <a:solidFill>
                   <a:srgbClr val="5E6A78"/>
@@ -2674,7 +2745,7 @@
                 <a:ea typeface="Arial"/>
                 <a:cs typeface="Arial"/>
               </a:rPr>
-              <a:t>Technical demonstration, September 2026</a:t>
+              <a:t>Technical demonstration, September 8, 2026</a:t>
             </a:r>
           </a:p>
         </p:txBody>
@@ -2713,6 +2784,7 @@
           <a:lstStyle xmlns:a="http://schemas.openxmlformats.org/drawingml/2006/main"/>
           <a:p xmlns:a="http://schemas.openxmlformats.org/drawingml/2006/main">
             <a:pPr algn="l">
+              <a:buNone/>
               <a:defRPr sz="1275" b="0">
                 <a:solidFill>
                   <a:srgbClr val="5E6A78"/>
@@ -2799,6 +2871,7 @@
           <a:lstStyle xmlns:a="http://schemas.openxmlformats.org/drawingml/2006/main"/>
           <a:p xmlns:a="http://schemas.openxmlformats.org/drawingml/2006/main">
             <a:pPr algn="l">
+              <a:buNone/>
               <a:defRPr sz="3300" b="1">
                 <a:solidFill>
                   <a:srgbClr val="142D4E"/>
@@ -2856,6 +2929,7 @@
           <a:lstStyle xmlns:a="http://schemas.openxmlformats.org/drawingml/2006/main"/>
           <a:p xmlns:a="http://schemas.openxmlformats.org/drawingml/2006/main">
             <a:pPr algn="l">
+              <a:buNone/>
               <a:defRPr sz="1275" b="0">
                 <a:solidFill>
                   <a:srgbClr val="5E6A78"/>
@@ -2913,6 +2987,7 @@
           <a:lstStyle xmlns:a="http://schemas.openxmlformats.org/drawingml/2006/main"/>
           <a:p xmlns:a="http://schemas.openxmlformats.org/drawingml/2006/main">
             <a:pPr algn="r">
+              <a:buNone/>
               <a:defRPr sz="1425" b="0">
                 <a:solidFill>
                   <a:srgbClr val="5E6A78"/>
@@ -2970,6 +3045,7 @@
           <a:lstStyle xmlns:a="http://schemas.openxmlformats.org/drawingml/2006/main"/>
           <a:p xmlns:a="http://schemas.openxmlformats.org/drawingml/2006/main">
             <a:pPr algn="l">
+              <a:buNone/>
               <a:defRPr sz="2250" b="1">
                 <a:solidFill>
                   <a:srgbClr val="142D4E"/>
@@ -3027,6 +3103,7 @@
           <a:lstStyle xmlns:a="http://schemas.openxmlformats.org/drawingml/2006/main"/>
           <a:p xmlns:a="http://schemas.openxmlformats.org/drawingml/2006/main">
             <a:pPr algn="l">
+              <a:buNone/>
               <a:defRPr sz="2175" b="0">
                 <a:solidFill>
                   <a:srgbClr val="26364B"/>
@@ -3084,6 +3161,7 @@
           <a:lstStyle xmlns:a="http://schemas.openxmlformats.org/drawingml/2006/main"/>
           <a:p xmlns:a="http://schemas.openxmlformats.org/drawingml/2006/main">
             <a:pPr algn="l">
+              <a:buNone/>
               <a:defRPr sz="2250" b="1">
                 <a:solidFill>
                   <a:srgbClr val="142D4E"/>
@@ -3146,6 +3224,7 @@
           <a:lstStyle xmlns:a="http://schemas.openxmlformats.org/drawingml/2006/main"/>
           <a:p xmlns:a="http://schemas.openxmlformats.org/drawingml/2006/main">
             <a:pPr algn="ctr">
+              <a:buNone/>
               <a:defRPr sz="1800" b="1">
                 <a:solidFill>
                   <a:srgbClr val="2463A6"/>
@@ -3169,6 +3248,7 @@
           </a:p>
           <a:p xmlns:a="http://schemas.openxmlformats.org/drawingml/2006/main">
             <a:pPr algn="ctr">
+              <a:buNone/>
               <a:defRPr sz="1800" b="1">
                 <a:solidFill>
                   <a:srgbClr val="2463A6"/>
@@ -3231,6 +3311,7 @@
           <a:lstStyle xmlns:a="http://schemas.openxmlformats.org/drawingml/2006/main"/>
           <a:p xmlns:a="http://schemas.openxmlformats.org/drawingml/2006/main">
             <a:pPr algn="ctr">
+              <a:buNone/>
               <a:defRPr sz="1800" b="1">
                 <a:solidFill>
                   <a:srgbClr val="2463A6"/>
@@ -3254,6 +3335,7 @@
           </a:p>
           <a:p xmlns:a="http://schemas.openxmlformats.org/drawingml/2006/main">
             <a:pPr algn="ctr">
+              <a:buNone/>
               <a:defRPr sz="1800" b="1">
                 <a:solidFill>
                   <a:srgbClr val="2463A6"/>
@@ -3316,6 +3398,7 @@
           <a:lstStyle xmlns:a="http://schemas.openxmlformats.org/drawingml/2006/main"/>
           <a:p xmlns:a="http://schemas.openxmlformats.org/drawingml/2006/main">
             <a:pPr algn="ctr">
+              <a:buNone/>
               <a:defRPr sz="1800" b="1">
                 <a:solidFill>
                   <a:srgbClr val="2463A6"/>
@@ -3339,6 +3422,7 @@
           </a:p>
           <a:p xmlns:a="http://schemas.openxmlformats.org/drawingml/2006/main">
             <a:pPr algn="ctr">
+              <a:buNone/>
               <a:defRPr sz="1800" b="1">
                 <a:solidFill>
                   <a:srgbClr val="2463A6"/>
@@ -3364,7 +3448,7 @@
       </p:sp>
       <p:cxnSp>
         <p:nvCxnSpPr>
-          <p:cNvPr id="23" name=""/>
+          <p:cNvPr id="34" name=""/>
           <p:cNvCxnSpPr>
             <a:stCxn xmlns:a="http://schemas.openxmlformats.org/drawingml/2006/main" id="7" idx="3"/>
             <a:endCxn xmlns:a="http://schemas.openxmlformats.org/drawingml/2006/main" id="8" idx="1"/>
@@ -3390,7 +3474,7 @@
       </p:cxnSp>
       <p:cxnSp>
         <p:nvCxnSpPr>
-          <p:cNvPr id="24" name=""/>
+          <p:cNvPr id="35" name=""/>
           <p:cNvCxnSpPr>
             <a:stCxn xmlns:a="http://schemas.openxmlformats.org/drawingml/2006/main" id="8" idx="3"/>
             <a:endCxn xmlns:a="http://schemas.openxmlformats.org/drawingml/2006/main" id="9" idx="1"/>
@@ -3448,6 +3532,7 @@
           <a:lstStyle xmlns:a="http://schemas.openxmlformats.org/drawingml/2006/main"/>
           <a:p xmlns:a="http://schemas.openxmlformats.org/drawingml/2006/main">
             <a:pPr algn="l">
+              <a:buNone/>
               <a:defRPr sz="2025" b="1">
                 <a:solidFill>
                   <a:srgbClr val="2463A6"/>
@@ -3505,6 +3590,7 @@
           <a:lstStyle xmlns:a="http://schemas.openxmlformats.org/drawingml/2006/main"/>
           <a:p xmlns:a="http://schemas.openxmlformats.org/drawingml/2006/main">
             <a:pPr algn="l">
+              <a:buNone/>
               <a:defRPr sz="1800" b="0">
                 <a:solidFill>
                   <a:srgbClr val="5E6A78"/>
@@ -3528,6 +3614,7 @@
           </a:p>
           <a:p xmlns:a="http://schemas.openxmlformats.org/drawingml/2006/main">
             <a:pPr algn="l">
+              <a:buNone/>
               <a:defRPr sz="1800" b="0">
                 <a:solidFill>
                   <a:srgbClr val="5E6A78"/>
@@ -3614,6 +3701,7 @@
           <a:lstStyle xmlns:a="http://schemas.openxmlformats.org/drawingml/2006/main"/>
           <a:p xmlns:a="http://schemas.openxmlformats.org/drawingml/2006/main">
             <a:pPr algn="l">
+              <a:buNone/>
               <a:defRPr sz="3300" b="1">
                 <a:solidFill>
                   <a:srgbClr val="142D4E"/>
@@ -3632,7 +3720,7 @@
                 <a:ea typeface="Arial"/>
                 <a:cs typeface="Arial"/>
               </a:rPr>
-              <a:t>Recovery after real local process outages</a:t>
+              <a:t>Incident email notifications</a:t>
             </a:r>
           </a:p>
         </p:txBody>
@@ -3671,6 +3759,7 @@
           <a:lstStyle xmlns:a="http://schemas.openxmlformats.org/drawingml/2006/main"/>
           <a:p xmlns:a="http://schemas.openxmlformats.org/drawingml/2006/main">
             <a:pPr algn="l">
+              <a:buNone/>
               <a:defRPr sz="1800" b="0">
                 <a:solidFill>
                   <a:srgbClr val="5E6A78"/>
@@ -3689,7 +3778,7 @@
                 <a:ea typeface="Arial"/>
                 <a:cs typeface="Arial"/>
               </a:rPr>
-              <a:t>September 6 run: two databases and embedded ActiveMQ</a:t>
+              <a:t>Audit/Protected commits incident evidence and notification_outbox together</a:t>
             </a:r>
           </a:p>
         </p:txBody>
@@ -3728,6 +3817,7 @@
           <a:lstStyle xmlns:a="http://schemas.openxmlformats.org/drawingml/2006/main"/>
           <a:p xmlns:a="http://schemas.openxmlformats.org/drawingml/2006/main">
             <a:pPr algn="l">
+              <a:buNone/>
               <a:defRPr sz="1275" b="0">
                 <a:solidFill>
                   <a:srgbClr val="5E6A78"/>
@@ -3785,6 +3875,7 @@
           <a:lstStyle xmlns:a="http://schemas.openxmlformats.org/drawingml/2006/main"/>
           <a:p xmlns:a="http://schemas.openxmlformats.org/drawingml/2006/main">
             <a:pPr algn="r">
+              <a:buNone/>
               <a:defRPr sz="1425" b="0">
                 <a:solidFill>
                   <a:srgbClr val="5E6A78"/>
@@ -3810,7 +3901,7 @@
       </p:sp>
       <p:graphicFrame>
         <p:nvGraphicFramePr>
-          <p:cNvPr id="12" name=""/>
+          <p:cNvPr id="14" name=""/>
           <p:cNvGraphicFramePr/>
           <p:nvPr/>
         </p:nvGraphicFramePr>
@@ -3844,7 +3935,7 @@
                           <a:ea typeface="Arial"/>
                           <a:cs typeface="Arial"/>
                         </a:rPr>
-                        <a:t>Stopped service</a:t>
+                        <a:t>Observed scenario</a:t>
                       </a:r>
                     </a:p>
                   </a:txBody>
@@ -3870,7 +3961,7 @@
                           <a:ea typeface="Arial"/>
                           <a:cs typeface="Arial"/>
                         </a:rPr>
-                        <a:t>During outage</a:t>
+                        <a:t>Protected result</a:t>
                       </a:r>
                     </a:p>
                   </a:txBody>
@@ -3896,7 +3987,7 @@
                           <a:ea typeface="Arial"/>
                           <a:cs typeface="Arial"/>
                         </a:rPr>
-                        <a:t>After restart</a:t>
+                        <a:t>Local email observation</a:t>
                       </a:r>
                     </a:p>
                   </a:txBody>
@@ -3924,7 +4015,20 @@
                           <a:ea typeface="Arial"/>
                           <a:cs typeface="Arial"/>
                         </a:rPr>
-                        <a:t>Processor</a:t>
+                        <a:t>Fabricated</a:t>
+                      </a:r>
+                    </a:p>
+                    <a:p>
+                      <a:r>
+                        <a:rPr sz="2025" b="0">
+                          <a:solidFill>
+                            <a:srgbClr val="26364B"/>
+                          </a:solidFill>
+                          <a:latin typeface="Arial"/>
+                          <a:ea typeface="Arial"/>
+                          <a:cs typeface="Arial"/>
+                        </a:rPr>
+                        <a:t>Primary record</a:t>
                       </a:r>
                     </a:p>
                   </a:txBody>
@@ -3950,7 +4054,7 @@
                           <a:ea typeface="Arial"/>
                           <a:cs typeface="Arial"/>
                         </a:rPr>
-                        <a:t>HTTP 503 after publication</a:t>
+                        <a:t>Quarantined</a:t>
                       </a:r>
                     </a:p>
                     <a:p>
@@ -3963,7 +4067,7 @@
                           <a:ea typeface="Arial"/>
                           <a:cs typeface="Arial"/>
                         </a:rPr>
-                        <a:t>Zero postings</a:t>
+                        <a:t>No financial effect</a:t>
                       </a:r>
                     </a:p>
                   </a:txBody>
@@ -3989,7 +4093,7 @@
                           <a:ea typeface="Arial"/>
                           <a:cs typeface="Arial"/>
                         </a:rPr>
-                        <a:t>Protected job recovery</a:t>
+                        <a:t>One captured alert</a:t>
                       </a:r>
                     </a:p>
                     <a:p>
@@ -4002,7 +4106,7 @@
                           <a:ea typeface="Arial"/>
                           <a:cs typeface="Arial"/>
                         </a:rPr>
-                        <a:t>Same-key retry adds no effect</a:t>
+                        <a:t>Minimal incident metadata</a:t>
                       </a:r>
                     </a:p>
                   </a:txBody>
@@ -4030,7 +4134,7 @@
                           <a:ea typeface="Arial"/>
                           <a:cs typeface="Arial"/>
                         </a:rPr>
-                        <a:t>Key service</a:t>
+                        <a:t>Tampering after</a:t>
                       </a:r>
                     </a:p>
                     <a:p>
@@ -4043,7 +4147,7 @@
                           <a:ea typeface="Arial"/>
                           <a:cs typeface="Arial"/>
                         </a:rPr>
-                        <a:t>before new issue</a:t>
+                        <a:t>settlement</a:t>
                       </a:r>
                     </a:p>
                   </a:txBody>
@@ -4069,7 +4173,7 @@
                           <a:ea typeface="Arial"/>
                           <a:cs typeface="Arial"/>
                         </a:rPr>
-                        <a:t>HTTP 503</a:t>
+                        <a:t>Original completed result</a:t>
                       </a:r>
                     </a:p>
                     <a:p>
@@ -4082,7 +4186,7 @@
                           <a:ea typeface="Arial"/>
                           <a:cs typeface="Arial"/>
                         </a:rPr>
-                        <a:t>No receipt or primary row</a:t>
+                        <a:t>remains unchanged</a:t>
                       </a:r>
                     </a:p>
                   </a:txBody>
@@ -4108,7 +4212,7 @@
                           <a:ea typeface="Arial"/>
                           <a:cs typeface="Arial"/>
                         </a:rPr>
-                        <a:t>Same request succeeds</a:t>
+                        <a:t>One captured alert</a:t>
                       </a:r>
                     </a:p>
                     <a:p>
@@ -4121,7 +4225,7 @@
                           <a:ea typeface="Arial"/>
                           <a:cs typeface="Arial"/>
                         </a:rPr>
-                        <a:t>One financial effect</a:t>
+                        <a:t>Separate human review</a:t>
                       </a:r>
                     </a:p>
                   </a:txBody>
@@ -4170,6 +4274,7 @@
           <a:lstStyle xmlns:a="http://schemas.openxmlformats.org/drawingml/2006/main"/>
           <a:p xmlns:a="http://schemas.openxmlformats.org/drawingml/2006/main">
             <a:pPr algn="l">
+              <a:buNone/>
               <a:defRPr sz="2175" b="1">
                 <a:solidFill>
                   <a:srgbClr val="2463A6"/>
@@ -4188,7 +4293,31 @@
                 <a:ea typeface="Arial"/>
                 <a:cs typeface="Arial"/>
               </a:rPr>
-              <a:t>Invalid content enters quarantine. Dependency failures remain retryable.</a:t>
+              <a:t>A separate dispatcher retries SMTP with a rate cap.</a:t>
+            </a:r>
+          </a:p>
+          <a:p xmlns:a="http://schemas.openxmlformats.org/drawingml/2006/main">
+            <a:pPr algn="l">
+              <a:buNone/>
+              <a:defRPr sz="2175" b="1">
+                <a:solidFill>
+                  <a:srgbClr val="2463A6"/>
+                </a:solidFill>
+                <a:latin typeface="Arial"/>
+                <a:ea typeface="Arial"/>
+                <a:cs typeface="Arial"/>
+              </a:defRPr>
+            </a:pPr>
+            <a:r>
+              <a:rPr sz="2175" b="1">
+                <a:solidFill>
+                  <a:srgbClr val="2463A6"/>
+                </a:solidFill>
+                <a:latin typeface="Arial"/>
+                <a:ea typeface="Arial"/>
+                <a:cs typeface="Arial"/>
+              </a:rPr>
+              <a:t>At-least-once delivery. Email never gates settlement.</a:t>
             </a:r>
           </a:p>
         </p:txBody>
@@ -4227,6 +4356,7 @@
           <a:lstStyle xmlns:a="http://schemas.openxmlformats.org/drawingml/2006/main"/>
           <a:p xmlns:a="http://schemas.openxmlformats.org/drawingml/2006/main">
             <a:pPr algn="l">
+              <a:buNone/>
               <a:defRPr sz="1650" b="0">
                 <a:solidFill>
                   <a:srgbClr val="5E6A78"/>
@@ -4245,7 +4375,7 @@
                 <a:ea typeface="Arial"/>
                 <a:cs typeface="Arial"/>
               </a:rPr>
-              <a:t>Not covered here: power loss, database outages or in-flight key-service failure.</a:t>
+              <a:t>Mailpit captures locally. Gmail delivery requires configured authenticated SMTP.</a:t>
             </a:r>
           </a:p>
         </p:txBody>
@@ -4313,6 +4443,7 @@
           <a:lstStyle xmlns:a="http://schemas.openxmlformats.org/drawingml/2006/main"/>
           <a:p xmlns:a="http://schemas.openxmlformats.org/drawingml/2006/main">
             <a:pPr algn="l">
+              <a:buNone/>
               <a:defRPr sz="3300" b="1">
                 <a:solidFill>
                   <a:srgbClr val="142D4E"/>
@@ -4331,7 +4462,7 @@
                 <a:ea typeface="Arial"/>
                 <a:cs typeface="Arial"/>
               </a:rPr>
-              <a:t>Measured workload: 2,400 unique transfers</a:t>
+              <a:t>Measured workload and current checks</a:t>
             </a:r>
           </a:p>
         </p:txBody>
@@ -4370,6 +4501,7 @@
           <a:lstStyle xmlns:a="http://schemas.openxmlformats.org/drawingml/2006/main"/>
           <a:p xmlns:a="http://schemas.openxmlformats.org/drawingml/2006/main">
             <a:pPr algn="l">
+              <a:buNone/>
               <a:defRPr sz="1800" b="0">
                 <a:solidFill>
                   <a:srgbClr val="5E6A78"/>
@@ -4388,7 +4520,7 @@
                 <a:ea typeface="Arial"/>
                 <a:cs typeface="Arial"/>
               </a:rPr>
-              <a:t>September 6: two databases + embedded ActiveMQ. 20 offered TPS for 120 seconds.</a:t>
+              <a:t>Latest load: September 7. Offered 20 TPS for 120 seconds, before notifications.</a:t>
             </a:r>
           </a:p>
         </p:txBody>
@@ -4427,6 +4559,7 @@
           <a:lstStyle xmlns:a="http://schemas.openxmlformats.org/drawingml/2006/main"/>
           <a:p xmlns:a="http://schemas.openxmlformats.org/drawingml/2006/main">
             <a:pPr algn="l">
+              <a:buNone/>
               <a:defRPr sz="1275" b="0">
                 <a:solidFill>
                   <a:srgbClr val="5E6A78"/>
@@ -4484,6 +4617,7 @@
           <a:lstStyle xmlns:a="http://schemas.openxmlformats.org/drawingml/2006/main"/>
           <a:p xmlns:a="http://schemas.openxmlformats.org/drawingml/2006/main">
             <a:pPr algn="r">
+              <a:buNone/>
               <a:defRPr sz="1425" b="0">
                 <a:solidFill>
                   <a:srgbClr val="5E6A78"/>
@@ -4509,7 +4643,7 @@
       </p:sp>
       <p:graphicFrame>
         <p:nvGraphicFramePr>
-          <p:cNvPr id="11" name=""/>
+          <p:cNvPr id="13" name=""/>
           <p:cNvGraphicFramePr/>
           <p:nvPr/>
         </p:nvGraphicFramePr>
@@ -4542,7 +4676,7 @@
                           <a:ea typeface="Arial"/>
                           <a:cs typeface="Arial"/>
                         </a:rPr>
-                        <a:t>Measure</a:t>
+                        <a:t>Run or measure</a:t>
                       </a:r>
                     </a:p>
                   </a:txBody>
@@ -4596,7 +4730,7 @@
                           <a:ea typeface="Arial"/>
                           <a:cs typeface="Arial"/>
                         </a:rPr>
-                        <a:t>Steady completed rate, seconds 10–120</a:t>
+                        <a:t>September 7 steady completed rate</a:t>
                       </a:r>
                     </a:p>
                   </a:txBody>
@@ -4622,7 +4756,7 @@
                           <a:ea typeface="Arial"/>
                           <a:cs typeface="Arial"/>
                         </a:rPr>
-                        <a:t>20.3091 TPS</a:t>
+                        <a:t>19.963636 TPS</a:t>
                       </a:r>
                     </a:p>
                   </a:txBody>
@@ -4650,7 +4784,7 @@
                           <a:ea typeface="Arial"/>
                           <a:cs typeface="Arial"/>
                         </a:rPr>
-                        <a:t>Whole run, including warmup and drain</a:t>
+                        <a:t>Strict 20 TPS gate, zero tolerance</a:t>
                       </a:r>
                     </a:p>
                   </a:txBody>
@@ -4668,15 +4802,15 @@
                     <a:lstStyle/>
                     <a:p>
                       <a:r>
-                        <a:rPr sz="1950" b="0">
+                        <a:rPr sz="1950" b="1">
                           <a:solidFill>
-                            <a:srgbClr val="26364B"/>
+                            <a:srgbClr val="B43138"/>
                           </a:solidFill>
                           <a:latin typeface="Arial"/>
                           <a:ea typeface="Arial"/>
                           <a:cs typeface="Arial"/>
                         </a:rPr>
-                        <a:t>19.9371 TPS</a:t>
+                        <a:t>FAILED</a:t>
                       </a:r>
                     </a:p>
                   </a:txBody>
@@ -4704,7 +4838,7 @@
                           <a:ea typeface="Arial"/>
                           <a:cs typeface="Arial"/>
                         </a:rPr>
-                        <a:t>End-to-end completion latency, p95</a:t>
+                        <a:t>September 7 completed / failed operations</a:t>
                       </a:r>
                     </a:p>
                   </a:txBody>
@@ -4730,7 +4864,7 @@
                           <a:ea typeface="Arial"/>
                           <a:cs typeface="Arial"/>
                         </a:rPr>
-                        <a:t>3,990 ms</a:t>
+                        <a:t>2,400 / 0</a:t>
                       </a:r>
                     </a:p>
                   </a:txBody>
@@ -4758,7 +4892,7 @@
                           <a:ea typeface="Arial"/>
                           <a:cs typeface="Arial"/>
                         </a:rPr>
-                        <a:t>Automated Java tests</a:t>
+                        <a:t>September 7 completion latency, p95 / p99</a:t>
                       </a:r>
                     </a:p>
                   </a:txBody>
@@ -4784,7 +4918,7 @@
                           <a:ea typeface="Arial"/>
                           <a:cs typeface="Arial"/>
                         </a:rPr>
-                        <a:t>83 passed in recorded run</a:t>
+                        <a:t>668 ms / 791 ms</a:t>
                       </a:r>
                     </a:p>
                   </a:txBody>
@@ -4812,7 +4946,7 @@
                           <a:ea typeface="Arial"/>
                           <a:cs typeface="Arial"/>
                         </a:rPr>
-                        <a:t>PostgreSQL functional and attack scenarios</a:t>
+                        <a:t>September 6 initial run: 83 Java tests</a:t>
                       </a:r>
                     </a:p>
                   </a:txBody>
@@ -4838,7 +4972,7 @@
                           <a:ea typeface="Arial"/>
                           <a:cs typeface="Arial"/>
                         </a:rPr>
-                        <a:t>15 passed</a:t>
+                        <a:t>20.3091 TPS, passed</a:t>
                       </a:r>
                     </a:p>
                   </a:txBody>
@@ -4866,7 +5000,7 @@
                           <a:ea typeface="Arial"/>
                           <a:cs typeface="Arial"/>
                         </a:rPr>
-                        <a:t>Real local JVM outage cases</a:t>
+                        <a:t>September 6 final run: 86 Java tests</a:t>
                       </a:r>
                     </a:p>
                   </a:txBody>
@@ -4892,7 +5026,7 @@
                           <a:ea typeface="Arial"/>
                           <a:cs typeface="Arial"/>
                         </a:rPr>
-                        <a:t>2 passed</a:t>
+                        <a:t>20.0000 TPS, passed</a:t>
                       </a:r>
                     </a:p>
                   </a:txBody>
@@ -4941,6 +5075,7 @@
           <a:lstStyle xmlns:a="http://schemas.openxmlformats.org/drawingml/2006/main"/>
           <a:p xmlns:a="http://schemas.openxmlformats.org/drawingml/2006/main">
             <a:pPr algn="l">
+              <a:buNone/>
               <a:defRPr sz="1725" b="0">
                 <a:solidFill>
                   <a:srgbClr val="5E6A78"/>
@@ -4959,11 +5094,12 @@
                 <a:ea typeface="Arial"/>
                 <a:cs typeface="Arial"/>
               </a:rPr>
-              <a:t>One Windows host, local software keys and simulated USD.</a:t>
+              <a:t>September 8: 137 Java tests, 44 Node checks, 18 role checks and 4 live cases passed.</a:t>
             </a:r>
           </a:p>
           <a:p xmlns:a="http://schemas.openxmlformats.org/drawingml/2006/main">
             <a:pPr algn="l">
+              <a:buNone/>
               <a:defRPr sz="1725" b="0">
                 <a:solidFill>
                   <a:srgbClr val="5E6A78"/>
@@ -4982,7 +5118,7 @@
                 <a:ea typeface="Arial"/>
                 <a:cs typeface="Arial"/>
               </a:rPr>
-              <a:t>These results do not establish maximum capacity, comparative cost or a production SLA.</a:t>
+              <a:t>No new load run. These checks establish neither email capacity nor a production SLA.</a:t>
             </a:r>
           </a:p>
         </p:txBody>
@@ -5050,6 +5186,7 @@
           <a:lstStyle xmlns:a="http://schemas.openxmlformats.org/drawingml/2006/main"/>
           <a:p xmlns:a="http://schemas.openxmlformats.org/drawingml/2006/main">
             <a:pPr algn="l">
+              <a:buNone/>
               <a:defRPr sz="3300" b="1">
                 <a:solidFill>
                   <a:srgbClr val="142D4E"/>
@@ -5107,6 +5244,7 @@
           <a:lstStyle xmlns:a="http://schemas.openxmlformats.org/drawingml/2006/main"/>
           <a:p xmlns:a="http://schemas.openxmlformats.org/drawingml/2006/main">
             <a:pPr algn="l">
+              <a:buNone/>
               <a:defRPr sz="1800" b="0">
                 <a:solidFill>
                   <a:srgbClr val="5E6A78"/>
@@ -5164,6 +5302,7 @@
           <a:lstStyle xmlns:a="http://schemas.openxmlformats.org/drawingml/2006/main"/>
           <a:p xmlns:a="http://schemas.openxmlformats.org/drawingml/2006/main">
             <a:pPr algn="l">
+              <a:buNone/>
               <a:defRPr sz="1275" b="0">
                 <a:solidFill>
                   <a:srgbClr val="5E6A78"/>
@@ -5221,6 +5360,7 @@
           <a:lstStyle xmlns:a="http://schemas.openxmlformats.org/drawingml/2006/main"/>
           <a:p xmlns:a="http://schemas.openxmlformats.org/drawingml/2006/main">
             <a:pPr algn="r">
+              <a:buNone/>
               <a:defRPr sz="1425" b="0">
                 <a:solidFill>
                   <a:srgbClr val="5E6A78"/>
@@ -5283,6 +5423,7 @@
           <a:lstStyle xmlns:a="http://schemas.openxmlformats.org/drawingml/2006/main"/>
           <a:p xmlns:a="http://schemas.openxmlformats.org/drawingml/2006/main">
             <a:pPr algn="ctr">
+              <a:buNone/>
               <a:defRPr sz="1800" b="1">
                 <a:solidFill>
                   <a:srgbClr val="2463A6"/>
@@ -5306,6 +5447,7 @@
           </a:p>
           <a:p xmlns:a="http://schemas.openxmlformats.org/drawingml/2006/main">
             <a:pPr algn="ctr">
+              <a:buNone/>
               <a:defRPr sz="1800" b="1">
                 <a:solidFill>
                   <a:srgbClr val="2463A6"/>
@@ -5368,6 +5510,7 @@
           <a:lstStyle xmlns:a="http://schemas.openxmlformats.org/drawingml/2006/main"/>
           <a:p xmlns:a="http://schemas.openxmlformats.org/drawingml/2006/main">
             <a:pPr algn="ctr">
+              <a:buNone/>
               <a:defRPr sz="1800" b="1">
                 <a:solidFill>
                   <a:srgbClr val="B43138"/>
@@ -5391,6 +5534,7 @@
           </a:p>
           <a:p xmlns:a="http://schemas.openxmlformats.org/drawingml/2006/main">
             <a:pPr algn="ctr">
+              <a:buNone/>
               <a:defRPr sz="1800" b="1">
                 <a:solidFill>
                   <a:srgbClr val="B43138"/>
@@ -5453,6 +5597,7 @@
           <a:lstStyle xmlns:a="http://schemas.openxmlformats.org/drawingml/2006/main"/>
           <a:p xmlns:a="http://schemas.openxmlformats.org/drawingml/2006/main">
             <a:pPr algn="ctr">
+              <a:buNone/>
               <a:defRPr sz="1800" b="1">
                 <a:solidFill>
                   <a:srgbClr val="916000"/>
@@ -5476,6 +5621,7 @@
           </a:p>
           <a:p xmlns:a="http://schemas.openxmlformats.org/drawingml/2006/main">
             <a:pPr algn="ctr">
+              <a:buNone/>
               <a:defRPr sz="1800" b="1">
                 <a:solidFill>
                   <a:srgbClr val="916000"/>
@@ -5538,6 +5684,7 @@
           <a:lstStyle xmlns:a="http://schemas.openxmlformats.org/drawingml/2006/main"/>
           <a:p xmlns:a="http://schemas.openxmlformats.org/drawingml/2006/main">
             <a:pPr algn="ctr">
+              <a:buNone/>
               <a:defRPr sz="1800" b="1">
                 <a:solidFill>
                   <a:srgbClr val="2463A6"/>
@@ -5561,6 +5708,7 @@
           </a:p>
           <a:p xmlns:a="http://schemas.openxmlformats.org/drawingml/2006/main">
             <a:pPr algn="ctr">
+              <a:buNone/>
               <a:defRPr sz="1800" b="1">
                 <a:solidFill>
                   <a:srgbClr val="2463A6"/>
@@ -5623,6 +5771,7 @@
           <a:lstStyle xmlns:a="http://schemas.openxmlformats.org/drawingml/2006/main"/>
           <a:p xmlns:a="http://schemas.openxmlformats.org/drawingml/2006/main">
             <a:pPr algn="ctr">
+              <a:buNone/>
               <a:defRPr sz="1800" b="1">
                 <a:solidFill>
                   <a:srgbClr val="2463A6"/>
@@ -5646,6 +5795,7 @@
           </a:p>
           <a:p xmlns:a="http://schemas.openxmlformats.org/drawingml/2006/main">
             <a:pPr algn="ctr">
+              <a:buNone/>
               <a:defRPr sz="1800" b="1">
                 <a:solidFill>
                   <a:srgbClr val="2463A6"/>
@@ -5708,6 +5858,7 @@
           <a:lstStyle xmlns:a="http://schemas.openxmlformats.org/drawingml/2006/main"/>
           <a:p xmlns:a="http://schemas.openxmlformats.org/drawingml/2006/main">
             <a:pPr algn="ctr">
+              <a:buNone/>
               <a:defRPr sz="1800" b="1">
                 <a:solidFill>
                   <a:srgbClr val="916000"/>
@@ -5731,6 +5882,7 @@
           </a:p>
           <a:p xmlns:a="http://schemas.openxmlformats.org/drawingml/2006/main">
             <a:pPr algn="ctr">
+              <a:buNone/>
               <a:defRPr sz="1800" b="1">
                 <a:solidFill>
                   <a:srgbClr val="916000"/>
@@ -5756,7 +5908,7 @@
       </p:sp>
       <p:cxnSp>
         <p:nvCxnSpPr>
-          <p:cNvPr id="29" name=""/>
+          <p:cNvPr id="46" name=""/>
           <p:cNvCxnSpPr>
             <a:stCxn xmlns:a="http://schemas.openxmlformats.org/drawingml/2006/main" id="5" idx="3"/>
             <a:endCxn xmlns:a="http://schemas.openxmlformats.org/drawingml/2006/main" id="7" idx="1"/>
@@ -5782,7 +5934,7 @@
       </p:cxnSp>
       <p:cxnSp>
         <p:nvCxnSpPr>
-          <p:cNvPr id="30" name=""/>
+          <p:cNvPr id="47" name=""/>
           <p:cNvCxnSpPr>
             <a:stCxn xmlns:a="http://schemas.openxmlformats.org/drawingml/2006/main" id="5" idx="2"/>
             <a:endCxn xmlns:a="http://schemas.openxmlformats.org/drawingml/2006/main" id="6" idx="0"/>
@@ -5808,7 +5960,7 @@
       </p:cxnSp>
       <p:cxnSp>
         <p:nvCxnSpPr>
-          <p:cNvPr id="31" name=""/>
+          <p:cNvPr id="48" name=""/>
           <p:cNvCxnSpPr>
             <a:stCxn xmlns:a="http://schemas.openxmlformats.org/drawingml/2006/main" id="7" idx="3"/>
             <a:endCxn xmlns:a="http://schemas.openxmlformats.org/drawingml/2006/main" id="9" idx="1"/>
@@ -5834,7 +5986,7 @@
       </p:cxnSp>
       <p:cxnSp>
         <p:nvCxnSpPr>
-          <p:cNvPr id="32" name=""/>
+          <p:cNvPr id="49" name=""/>
           <p:cNvCxnSpPr>
             <a:stCxn xmlns:a="http://schemas.openxmlformats.org/drawingml/2006/main" id="6" idx="3"/>
             <a:endCxn xmlns:a="http://schemas.openxmlformats.org/drawingml/2006/main" id="8" idx="1"/>
@@ -5860,7 +6012,7 @@
       </p:cxnSp>
       <p:cxnSp>
         <p:nvCxnSpPr>
-          <p:cNvPr id="33" name=""/>
+          <p:cNvPr id="50" name=""/>
           <p:cNvCxnSpPr>
             <a:stCxn xmlns:a="http://schemas.openxmlformats.org/drawingml/2006/main" id="7" idx="2"/>
             <a:endCxn xmlns:a="http://schemas.openxmlformats.org/drawingml/2006/main" id="8" idx="0"/>
@@ -5886,7 +6038,7 @@
       </p:cxnSp>
       <p:cxnSp>
         <p:nvCxnSpPr>
-          <p:cNvPr id="34" name=""/>
+          <p:cNvPr id="51" name=""/>
           <p:cNvCxnSpPr>
             <a:stCxn xmlns:a="http://schemas.openxmlformats.org/drawingml/2006/main" id="9" idx="2"/>
             <a:endCxn xmlns:a="http://schemas.openxmlformats.org/drawingml/2006/main" id="10" idx="0"/>
@@ -5912,7 +6064,7 @@
       </p:cxnSp>
       <p:cxnSp>
         <p:nvCxnSpPr>
-          <p:cNvPr id="35" name=""/>
+          <p:cNvPr id="52" name=""/>
           <p:cNvCxnSpPr>
             <a:stCxn xmlns:a="http://schemas.openxmlformats.org/drawingml/2006/main" id="8" idx="3"/>
             <a:endCxn xmlns:a="http://schemas.openxmlformats.org/drawingml/2006/main" id="9" idx="1"/>
@@ -5972,6 +6124,7 @@
           <a:lstStyle xmlns:a="http://schemas.openxmlformats.org/drawingml/2006/main"/>
           <a:p xmlns:a="http://schemas.openxmlformats.org/drawingml/2006/main">
             <a:pPr algn="l">
+              <a:buNone/>
               <a:defRPr sz="1725" b="0">
                 <a:solidFill>
                   <a:srgbClr val="5E6A78"/>
@@ -5995,6 +6148,7 @@
           </a:p>
           <a:p xmlns:a="http://schemas.openxmlformats.org/drawingml/2006/main">
             <a:pPr algn="l">
+              <a:buNone/>
               <a:defRPr sz="1725" b="0">
                 <a:solidFill>
                   <a:srgbClr val="5E6A78"/>
@@ -6081,6 +6235,7 @@
           <a:lstStyle xmlns:a="http://schemas.openxmlformats.org/drawingml/2006/main"/>
           <a:p xmlns:a="http://schemas.openxmlformats.org/drawingml/2006/main">
             <a:pPr algn="l">
+              <a:buNone/>
               <a:defRPr sz="3300" b="1">
                 <a:solidFill>
                   <a:srgbClr val="142D4E"/>
@@ -6138,6 +6293,7 @@
           <a:lstStyle xmlns:a="http://schemas.openxmlformats.org/drawingml/2006/main"/>
           <a:p xmlns:a="http://schemas.openxmlformats.org/drawingml/2006/main">
             <a:pPr algn="l">
+              <a:buNone/>
               <a:defRPr sz="1275" b="0">
                 <a:solidFill>
                   <a:srgbClr val="5E6A78"/>
@@ -6195,6 +6351,7 @@
           <a:lstStyle xmlns:a="http://schemas.openxmlformats.org/drawingml/2006/main"/>
           <a:p xmlns:a="http://schemas.openxmlformats.org/drawingml/2006/main">
             <a:pPr algn="r">
+              <a:buNone/>
               <a:defRPr sz="1425" b="0">
                 <a:solidFill>
                   <a:srgbClr val="5E6A78"/>
@@ -6252,6 +6409,7 @@
           <a:lstStyle xmlns:a="http://schemas.openxmlformats.org/drawingml/2006/main"/>
           <a:p xmlns:a="http://schemas.openxmlformats.org/drawingml/2006/main">
             <a:pPr algn="l">
+              <a:buNone/>
               <a:defRPr sz="2325" b="1">
                 <a:solidFill>
                   <a:srgbClr val="142D4E"/>
@@ -6419,6 +6577,7 @@
           <a:lstStyle xmlns:a="http://schemas.openxmlformats.org/drawingml/2006/main"/>
           <a:p xmlns:a="http://schemas.openxmlformats.org/drawingml/2006/main">
             <a:pPr algn="l">
+              <a:buNone/>
               <a:defRPr sz="2325" b="1">
                 <a:solidFill>
                   <a:srgbClr val="142D4E"/>
@@ -6437,7 +6596,7 @@
                 <a:ea typeface="Arial"/>
                 <a:cs typeface="Arial"/>
               </a:rPr>
-              <a:t>Three scenarios to explain</a:t>
+              <a:t>Local demonstration cases</a:t>
             </a:r>
           </a:p>
         </p:txBody>
@@ -6490,7 +6649,15 @@
               </a:defRPr>
             </a:pPr>
             <a:r>
-              <a:t>Normal transfer plus an identical retry</a:t>
+              <a:rPr sz="2025" b="0">
+                <a:solidFill>
+                  <a:srgbClr val="26364B"/>
+                </a:solidFill>
+                <a:latin typeface="Arial"/>
+                <a:ea typeface="Arial"/>
+                <a:cs typeface="Arial"/>
+              </a:rPr>
+              <a:t>Normal transfer and identical retry</a:t>
             </a:r>
           </a:p>
           <a:p xmlns:a="http://schemas.openxmlformats.org/drawingml/2006/main">
@@ -6509,7 +6676,15 @@
               </a:defRPr>
             </a:pPr>
             <a:r>
-              <a:t>Fabricated primary row with a fake MAC</a:t>
+              <a:rPr sz="2025" b="0">
+                <a:solidFill>
+                  <a:srgbClr val="26364B"/>
+                </a:solidFill>
+                <a:latin typeface="Arial"/>
+                <a:ea typeface="Arial"/>
+                <a:cs typeface="Arial"/>
+              </a:rPr>
+              <a:t>Fabricated row and captured alert</a:t>
             </a:r>
           </a:p>
           <a:p xmlns:a="http://schemas.openxmlformats.org/drawingml/2006/main">
@@ -6528,7 +6703,15 @@
               </a:defRPr>
             </a:pPr>
             <a:r>
-              <a:t>Post-verification tampering (test harness)</a:t>
+              <a:rPr sz="2025" b="0">
+                <a:solidFill>
+                  <a:srgbClr val="26364B"/>
+                </a:solidFill>
+                <a:latin typeface="Arial"/>
+                <a:ea typeface="Arial"/>
+                <a:cs typeface="Arial"/>
+              </a:rPr>
+              <a:t>Tampering after settlement and review</a:t>
             </a:r>
           </a:p>
         </p:txBody>
@@ -6567,7 +6750,8 @@
           <a:lstStyle xmlns:a="http://schemas.openxmlformats.org/drawingml/2006/main"/>
           <a:p xmlns:a="http://schemas.openxmlformats.org/drawingml/2006/main">
             <a:pPr algn="l">
-              <a:defRPr sz="2175" b="1">
+              <a:buNone/>
+              <a:defRPr sz="1875" b="1">
                 <a:solidFill>
                   <a:srgbClr val="2463A6"/>
                 </a:solidFill>
@@ -6577,7 +6761,7 @@
               </a:defRPr>
             </a:pPr>
             <a:r>
-              <a:rPr sz="2175" b="1">
+              <a:rPr sz="1875" b="1">
                 <a:solidFill>
                   <a:srgbClr val="2463A6"/>
                 </a:solidFill>
@@ -6585,12 +6769,13 @@
                 <a:ea typeface="Arial"/>
                 <a:cs typeface="Arial"/>
               </a:rPr>
-              <a:t>The next integration starts with one operation, one threat model</a:t>
+              <a:t>Evidence and code: github.com/ViktorKhudiaiev/demo_security_module</a:t>
             </a:r>
           </a:p>
           <a:p xmlns:a="http://schemas.openxmlformats.org/drawingml/2006/main">
             <a:pPr algn="l">
-              <a:defRPr sz="2175" b="1">
+              <a:buNone/>
+              <a:defRPr sz="1875" b="1">
                 <a:solidFill>
                   <a:srgbClr val="2463A6"/>
                 </a:solidFill>
@@ -6600,7 +6785,7 @@
               </a:defRPr>
             </a:pPr>
             <a:r>
-              <a:rPr sz="2175" b="1">
+              <a:rPr sz="1875" b="1">
                 <a:solidFill>
                   <a:srgbClr val="2463A6"/>
                 </a:solidFill>
@@ -6608,7 +6793,7 @@
                 <a:ea typeface="Arial"/>
                 <a:cs typeface="Arial"/>
               </a:rPr>
-              <a:t>and explicit acceptance criteria.</a:t>
+              <a:t>Code snapshot e2e35de. Full immutable links accompany the speaker notes.</a:t>
             </a:r>
           </a:p>
         </p:txBody>
@@ -6676,6 +6861,7 @@
           <a:lstStyle xmlns:a="http://schemas.openxmlformats.org/drawingml/2006/main"/>
           <a:p xmlns:a="http://schemas.openxmlformats.org/drawingml/2006/main">
             <a:pPr algn="l">
+              <a:buNone/>
               <a:defRPr sz="3300" b="1">
                 <a:solidFill>
                   <a:srgbClr val="142D4E"/>
@@ -6733,6 +6919,7 @@
           <a:lstStyle xmlns:a="http://schemas.openxmlformats.org/drawingml/2006/main"/>
           <a:p xmlns:a="http://schemas.openxmlformats.org/drawingml/2006/main">
             <a:pPr algn="l">
+              <a:buNone/>
               <a:defRPr sz="1800" b="0">
                 <a:solidFill>
                   <a:srgbClr val="5E6A78"/>
@@ -6790,6 +6977,7 @@
           <a:lstStyle xmlns:a="http://schemas.openxmlformats.org/drawingml/2006/main"/>
           <a:p xmlns:a="http://schemas.openxmlformats.org/drawingml/2006/main">
             <a:pPr algn="l">
+              <a:buNone/>
               <a:defRPr sz="1275" b="0">
                 <a:solidFill>
                   <a:srgbClr val="5E6A78"/>
@@ -6847,6 +7035,7 @@
           <a:lstStyle xmlns:a="http://schemas.openxmlformats.org/drawingml/2006/main"/>
           <a:p xmlns:a="http://schemas.openxmlformats.org/drawingml/2006/main">
             <a:pPr algn="r">
+              <a:buNone/>
               <a:defRPr sz="1425" b="0">
                 <a:solidFill>
                   <a:srgbClr val="5E6A78"/>
@@ -6872,7 +7061,7 @@
       </p:sp>
       <p:graphicFrame>
         <p:nvGraphicFramePr>
-          <p:cNvPr id="11" name=""/>
+          <p:cNvPr id="13" name=""/>
           <p:cNvGraphicFramePr/>
           <p:nvPr/>
         </p:nvGraphicFramePr>
@@ -7142,6 +7331,7 @@
           <a:lstStyle xmlns:a="http://schemas.openxmlformats.org/drawingml/2006/main"/>
           <a:p xmlns:a="http://schemas.openxmlformats.org/drawingml/2006/main">
             <a:pPr algn="l">
+              <a:buNone/>
               <a:defRPr sz="1950" b="0">
                 <a:solidFill>
                   <a:srgbClr val="5E6A78"/>
@@ -7165,6 +7355,7 @@
           </a:p>
           <a:p xmlns:a="http://schemas.openxmlformats.org/drawingml/2006/main">
             <a:pPr algn="l">
+              <a:buNone/>
               <a:defRPr sz="1950" b="0">
                 <a:solidFill>
                   <a:srgbClr val="5E6A78"/>
@@ -7251,6 +7442,7 @@
           <a:lstStyle xmlns:a="http://schemas.openxmlformats.org/drawingml/2006/main"/>
           <a:p xmlns:a="http://schemas.openxmlformats.org/drawingml/2006/main">
             <a:pPr algn="l">
+              <a:buNone/>
               <a:defRPr sz="3300" b="1">
                 <a:solidFill>
                   <a:srgbClr val="142D4E"/>
@@ -7308,6 +7500,7 @@
           <a:lstStyle xmlns:a="http://schemas.openxmlformats.org/drawingml/2006/main"/>
           <a:p xmlns:a="http://schemas.openxmlformats.org/drawingml/2006/main">
             <a:pPr algn="l">
+              <a:buNone/>
               <a:defRPr sz="1800" b="0">
                 <a:solidFill>
                   <a:srgbClr val="5E6A78"/>
@@ -7365,6 +7558,7 @@
           <a:lstStyle xmlns:a="http://schemas.openxmlformats.org/drawingml/2006/main"/>
           <a:p xmlns:a="http://schemas.openxmlformats.org/drawingml/2006/main">
             <a:pPr algn="l">
+              <a:buNone/>
               <a:defRPr sz="1275" b="0">
                 <a:solidFill>
                   <a:srgbClr val="5E6A78"/>
@@ -7422,6 +7616,7 @@
           <a:lstStyle xmlns:a="http://schemas.openxmlformats.org/drawingml/2006/main"/>
           <a:p xmlns:a="http://schemas.openxmlformats.org/drawingml/2006/main">
             <a:pPr algn="r">
+              <a:buNone/>
               <a:defRPr sz="1425" b="0">
                 <a:solidFill>
                   <a:srgbClr val="5E6A78"/>
@@ -7484,6 +7679,7 @@
           <a:lstStyle xmlns:a="http://schemas.openxmlformats.org/drawingml/2006/main"/>
           <a:p xmlns:a="http://schemas.openxmlformats.org/drawingml/2006/main">
             <a:pPr algn="ctr">
+              <a:buNone/>
               <a:defRPr sz="1800" b="1">
                 <a:solidFill>
                   <a:srgbClr val="2463A6"/>
@@ -7507,6 +7703,7 @@
           </a:p>
           <a:p xmlns:a="http://schemas.openxmlformats.org/drawingml/2006/main">
             <a:pPr algn="ctr">
+              <a:buNone/>
               <a:defRPr sz="1800" b="1">
                 <a:solidFill>
                   <a:srgbClr val="2463A6"/>
@@ -7569,6 +7766,7 @@
           <a:lstStyle xmlns:a="http://schemas.openxmlformats.org/drawingml/2006/main"/>
           <a:p xmlns:a="http://schemas.openxmlformats.org/drawingml/2006/main">
             <a:pPr algn="ctr">
+              <a:buNone/>
               <a:defRPr sz="1800" b="1">
                 <a:solidFill>
                   <a:srgbClr val="2463A6"/>
@@ -7592,6 +7790,7 @@
           </a:p>
           <a:p xmlns:a="http://schemas.openxmlformats.org/drawingml/2006/main">
             <a:pPr algn="ctr">
+              <a:buNone/>
               <a:defRPr sz="1800" b="1">
                 <a:solidFill>
                   <a:srgbClr val="2463A6"/>
@@ -7654,6 +7853,7 @@
           <a:lstStyle xmlns:a="http://schemas.openxmlformats.org/drawingml/2006/main"/>
           <a:p xmlns:a="http://schemas.openxmlformats.org/drawingml/2006/main">
             <a:pPr algn="ctr">
+              <a:buNone/>
               <a:defRPr sz="1800" b="1">
                 <a:solidFill>
                   <a:srgbClr val="B43138"/>
@@ -7677,6 +7877,7 @@
           </a:p>
           <a:p xmlns:a="http://schemas.openxmlformats.org/drawingml/2006/main">
             <a:pPr algn="ctr">
+              <a:buNone/>
               <a:defRPr sz="1800" b="1">
                 <a:solidFill>
                   <a:srgbClr val="B43138"/>
@@ -7739,6 +7940,7 @@
           <a:lstStyle xmlns:a="http://schemas.openxmlformats.org/drawingml/2006/main"/>
           <a:p xmlns:a="http://schemas.openxmlformats.org/drawingml/2006/main">
             <a:pPr algn="ctr">
+              <a:buNone/>
               <a:defRPr sz="1725" b="1">
                 <a:solidFill>
                   <a:srgbClr val="2463A6"/>
@@ -7762,6 +7964,7 @@
           </a:p>
           <a:p xmlns:a="http://schemas.openxmlformats.org/drawingml/2006/main">
             <a:pPr algn="ctr">
+              <a:buNone/>
               <a:defRPr sz="1725" b="1">
                 <a:solidFill>
                   <a:srgbClr val="2463A6"/>
@@ -7852,6 +8055,7 @@
           <a:lstStyle xmlns:a="http://schemas.openxmlformats.org/drawingml/2006/main"/>
           <a:p xmlns:a="http://schemas.openxmlformats.org/drawingml/2006/main">
             <a:pPr algn="l">
+              <a:buNone/>
               <a:defRPr sz="1500" b="1">
                 <a:solidFill>
                   <a:srgbClr val="142D4E"/>
@@ -7914,6 +8118,7 @@
           <a:lstStyle xmlns:a="http://schemas.openxmlformats.org/drawingml/2006/main"/>
           <a:p xmlns:a="http://schemas.openxmlformats.org/drawingml/2006/main">
             <a:pPr algn="ctr">
+              <a:buNone/>
               <a:defRPr sz="1725" b="1">
                 <a:solidFill>
                   <a:srgbClr val="2463A6"/>
@@ -7937,6 +8142,7 @@
           </a:p>
           <a:p xmlns:a="http://schemas.openxmlformats.org/drawingml/2006/main">
             <a:pPr algn="ctr">
+              <a:buNone/>
               <a:defRPr sz="1725" b="1">
                 <a:solidFill>
                   <a:srgbClr val="2463A6"/>
@@ -7999,6 +8205,7 @@
           <a:lstStyle xmlns:a="http://schemas.openxmlformats.org/drawingml/2006/main"/>
           <a:p xmlns:a="http://schemas.openxmlformats.org/drawingml/2006/main">
             <a:pPr algn="ctr">
+              <a:buNone/>
               <a:defRPr sz="1725" b="1">
                 <a:solidFill>
                   <a:srgbClr val="2463A6"/>
@@ -8022,6 +8229,7 @@
           </a:p>
           <a:p xmlns:a="http://schemas.openxmlformats.org/drawingml/2006/main">
             <a:pPr algn="ctr">
+              <a:buNone/>
               <a:defRPr sz="1725" b="1">
                 <a:solidFill>
                   <a:srgbClr val="2463A6"/>
@@ -8047,7 +8255,7 @@
       </p:sp>
       <p:cxnSp>
         <p:nvCxnSpPr>
-          <p:cNvPr id="38" name=""/>
+          <p:cNvPr id="66" name=""/>
           <p:cNvCxnSpPr>
             <a:stCxn xmlns:a="http://schemas.openxmlformats.org/drawingml/2006/main" id="5" idx="2"/>
             <a:endCxn xmlns:a="http://schemas.openxmlformats.org/drawingml/2006/main" id="6" idx="0"/>
@@ -8105,6 +8313,7 @@
           <a:lstStyle xmlns:a="http://schemas.openxmlformats.org/drawingml/2006/main"/>
           <a:p xmlns:a="http://schemas.openxmlformats.org/drawingml/2006/main">
             <a:pPr algn="l">
+              <a:buNone/>
               <a:defRPr sz="1575" b="0">
                 <a:solidFill>
                   <a:srgbClr val="2463A6"/>
@@ -8130,7 +8339,7 @@
       </p:sp>
       <p:cxnSp>
         <p:nvCxnSpPr>
-          <p:cNvPr id="40" name=""/>
+          <p:cNvPr id="68" name=""/>
           <p:cNvCxnSpPr>
             <a:stCxn xmlns:a="http://schemas.openxmlformats.org/drawingml/2006/main" id="5" idx="3"/>
             <a:endCxn xmlns:a="http://schemas.openxmlformats.org/drawingml/2006/main" id="7" idx="1"/>
@@ -8188,6 +8397,7 @@
           <a:lstStyle xmlns:a="http://schemas.openxmlformats.org/drawingml/2006/main"/>
           <a:p xmlns:a="http://schemas.openxmlformats.org/drawingml/2006/main">
             <a:pPr algn="l">
+              <a:buNone/>
               <a:defRPr sz="1575" b="0">
                 <a:solidFill>
                   <a:srgbClr val="2463A6"/>
@@ -8213,7 +8423,7 @@
       </p:sp>
       <p:cxnSp>
         <p:nvCxnSpPr>
-          <p:cNvPr id="42" name=""/>
+          <p:cNvPr id="70" name=""/>
           <p:cNvCxnSpPr>
             <a:stCxn xmlns:a="http://schemas.openxmlformats.org/drawingml/2006/main" id="6" idx="3"/>
             <a:endCxn xmlns:a="http://schemas.openxmlformats.org/drawingml/2006/main" id="8" idx="1"/>
@@ -8271,6 +8481,7 @@
           <a:lstStyle xmlns:a="http://schemas.openxmlformats.org/drawingml/2006/main"/>
           <a:p xmlns:a="http://schemas.openxmlformats.org/drawingml/2006/main">
             <a:pPr algn="l">
+              <a:buNone/>
               <a:defRPr sz="1500" b="0">
                 <a:solidFill>
                   <a:srgbClr val="2463A6"/>
@@ -8296,7 +8507,7 @@
       </p:sp>
       <p:cxnSp>
         <p:nvCxnSpPr>
-          <p:cNvPr id="44" name=""/>
+          <p:cNvPr id="72" name=""/>
           <p:cNvCxnSpPr>
             <a:stCxn xmlns:a="http://schemas.openxmlformats.org/drawingml/2006/main" id="7" idx="3"/>
             <a:endCxn xmlns:a="http://schemas.openxmlformats.org/drawingml/2006/main" id="11" idx="1"/>
@@ -8354,6 +8565,7 @@
           <a:lstStyle xmlns:a="http://schemas.openxmlformats.org/drawingml/2006/main"/>
           <a:p xmlns:a="http://schemas.openxmlformats.org/drawingml/2006/main">
             <a:pPr algn="l">
+              <a:buNone/>
               <a:defRPr sz="1500" b="0">
                 <a:solidFill>
                   <a:srgbClr val="B43138"/>
@@ -8379,7 +8591,7 @@
       </p:sp>
       <p:cxnSp>
         <p:nvCxnSpPr>
-          <p:cNvPr id="46" name=""/>
+          <p:cNvPr id="74" name=""/>
           <p:cNvCxnSpPr>
             <a:stCxn xmlns:a="http://schemas.openxmlformats.org/drawingml/2006/main" id="11" idx="2"/>
             <a:endCxn xmlns:a="http://schemas.openxmlformats.org/drawingml/2006/main" id="12" idx="0"/>
@@ -8437,6 +8649,7 @@
           <a:lstStyle xmlns:a="http://schemas.openxmlformats.org/drawingml/2006/main"/>
           <a:p xmlns:a="http://schemas.openxmlformats.org/drawingml/2006/main">
             <a:pPr algn="ctr">
+              <a:buNone/>
               <a:defRPr sz="1575" b="0">
                 <a:solidFill>
                   <a:srgbClr val="2463A6"/>
@@ -8460,6 +8673,7 @@
           </a:p>
           <a:p xmlns:a="http://schemas.openxmlformats.org/drawingml/2006/main">
             <a:pPr algn="ctr">
+              <a:buNone/>
               <a:defRPr sz="1575" b="0">
                 <a:solidFill>
                   <a:srgbClr val="2463A6"/>
@@ -8485,7 +8699,7 @@
       </p:sp>
       <p:cxnSp>
         <p:nvCxnSpPr>
-          <p:cNvPr id="48" name=""/>
+          <p:cNvPr id="76" name=""/>
           <p:cNvCxnSpPr>
             <a:stCxn xmlns:a="http://schemas.openxmlformats.org/drawingml/2006/main" id="12" idx="1"/>
             <a:endCxn xmlns:a="http://schemas.openxmlformats.org/drawingml/2006/main" id="8" idx="3"/>
@@ -8543,6 +8757,7 @@
           <a:lstStyle xmlns:a="http://schemas.openxmlformats.org/drawingml/2006/main"/>
           <a:p xmlns:a="http://schemas.openxmlformats.org/drawingml/2006/main">
             <a:pPr algn="l">
+              <a:buNone/>
               <a:defRPr sz="1500" b="0">
                 <a:solidFill>
                   <a:srgbClr val="2463A6"/>
@@ -8566,6 +8781,7 @@
           </a:p>
           <a:p xmlns:a="http://schemas.openxmlformats.org/drawingml/2006/main">
             <a:pPr algn="l">
+              <a:buNone/>
               <a:defRPr sz="1500" b="0">
                 <a:solidFill>
                   <a:srgbClr val="2463A6"/>
@@ -8623,6 +8839,7 @@
           <a:lstStyle xmlns:a="http://schemas.openxmlformats.org/drawingml/2006/main"/>
           <a:p xmlns:a="http://schemas.openxmlformats.org/drawingml/2006/main">
             <a:pPr algn="l">
+              <a:buNone/>
               <a:defRPr sz="1800" b="0">
                 <a:solidFill>
                   <a:srgbClr val="B43138"/>
@@ -8641,11 +8858,313 @@
                 <a:ea typeface="Arial"/>
                 <a:cs typeface="Arial"/>
               </a:rPr>
-              <a:t>Red identifies attacker-controlled Main. The broker never grants payment approval.</a:t>
-            </a:r>
-          </a:p>
-        </p:txBody>
-      </p:sp>
+              <a:t/>
+            </a:r>
+          </a:p>
+        </p:txBody>
+      </p:sp>
+      <p:sp>
+        <p:nvSpPr>
+          <p:cNvPr id="49" name="notification-capture">
+            <a:extLst xmlns:a="http://schemas.openxmlformats.org/drawingml/2006/main">
+              <a:ext uri="{FF2B5EF4-FFF2-40B4-BE49-F238E27FC236}">
+                <a16:creationId xmlns:a16="http://schemas.microsoft.com/office/drawing/2014/main" id="{18CE313A-BCF1-433B-AAE8-E49217D910E7}"/>
+              </a:ext>
+            </a:extLst>
+          </p:cNvPr>
+          <p:cNvSpPr>
+            <a:spLocks xmlns:a="http://schemas.openxmlformats.org/drawingml/2006/main" noGrp="1"/>
+          </p:cNvSpPr>
+          <p:nvPr/>
+        </p:nvSpPr>
+        <p:spPr>
+          <a:xfrm xmlns:a="http://schemas.openxmlformats.org/drawingml/2006/main">
+            <a:off x="619125" y="5619750"/>
+            <a:ext cx="3238500" cy="561975"/>
+          </a:xfrm>
+          <a:prstGeom xmlns:a="http://schemas.openxmlformats.org/drawingml/2006/main" prst="rect">
+            <a:avLst/>
+          </a:prstGeom>
+          <a:solidFill xmlns:a="http://schemas.openxmlformats.org/drawingml/2006/main">
+            <a:srgbClr val="FFFFFF"/>
+          </a:solidFill>
+          <a:ln xmlns:a="http://schemas.openxmlformats.org/drawingml/2006/main" w="19050">
+            <a:solidFill>
+              <a:srgbClr val="2463A6"/>
+            </a:solidFill>
+          </a:ln>
+        </p:spPr>
+        <p:txBody>
+          <a:bodyPr xmlns:a="http://schemas.openxmlformats.org/drawingml/2006/main" lIns="76200" tIns="38100" rIns="76200" bIns="38100" anchor="ctr">
+            <a:noAutofit/>
+          </a:bodyPr>
+          <a:lstStyle xmlns:a="http://schemas.openxmlformats.org/drawingml/2006/main"/>
+          <a:p xmlns:a="http://schemas.openxmlformats.org/drawingml/2006/main">
+            <a:pPr algn="ctr">
+              <a:defRPr sz="1650" b="1">
+                <a:solidFill>
+                  <a:srgbClr val="2463A6"/>
+                </a:solidFill>
+                <a:latin typeface="Arial"/>
+                <a:ea typeface="Arial"/>
+                <a:cs typeface="Arial"/>
+              </a:defRPr>
+            </a:pPr>
+            <a:r>
+              <a:rPr sz="1650" b="1">
+                <a:solidFill>
+                  <a:srgbClr val="2463A6"/>
+                </a:solidFill>
+                <a:latin typeface="Arial"/>
+                <a:ea typeface="Arial"/>
+                <a:cs typeface="Arial"/>
+              </a:rPr>
+              <a:t>Audit DB: incident +</a:t>
+            </a:r>
+          </a:p>
+          <a:p xmlns:a="http://schemas.openxmlformats.org/drawingml/2006/main">
+            <a:pPr algn="ctr">
+              <a:defRPr sz="1650" b="1">
+                <a:solidFill>
+                  <a:srgbClr val="2463A6"/>
+                </a:solidFill>
+                <a:latin typeface="Arial"/>
+                <a:ea typeface="Arial"/>
+                <a:cs typeface="Arial"/>
+              </a:defRPr>
+            </a:pPr>
+            <a:r>
+              <a:rPr sz="1650" b="1">
+                <a:solidFill>
+                  <a:srgbClr val="2463A6"/>
+                </a:solidFill>
+                <a:latin typeface="Arial"/>
+                <a:ea typeface="Arial"/>
+                <a:cs typeface="Arial"/>
+              </a:rPr>
+              <a:t>notification_outbox</a:t>
+            </a:r>
+          </a:p>
+        </p:txBody>
+      </p:sp>
+      <p:sp>
+        <p:nvSpPr>
+          <p:cNvPr id="50" name="notification-dispatcher">
+            <a:extLst xmlns:a="http://schemas.openxmlformats.org/drawingml/2006/main">
+              <a:ext uri="{FF2B5EF4-FFF2-40B4-BE49-F238E27FC236}">
+                <a16:creationId xmlns:a16="http://schemas.microsoft.com/office/drawing/2014/main" id="{859CE7E9-7AF7-4A47-A7A6-353545C0B45D}"/>
+              </a:ext>
+            </a:extLst>
+          </p:cNvPr>
+          <p:cNvSpPr>
+            <a:spLocks xmlns:a="http://schemas.openxmlformats.org/drawingml/2006/main" noGrp="1"/>
+          </p:cNvSpPr>
+          <p:nvPr/>
+        </p:nvSpPr>
+        <p:spPr>
+          <a:xfrm xmlns:a="http://schemas.openxmlformats.org/drawingml/2006/main">
+            <a:off x="4600575" y="5619750"/>
+            <a:ext cx="3238500" cy="561975"/>
+          </a:xfrm>
+          <a:prstGeom xmlns:a="http://schemas.openxmlformats.org/drawingml/2006/main" prst="rect">
+            <a:avLst/>
+          </a:prstGeom>
+          <a:solidFill xmlns:a="http://schemas.openxmlformats.org/drawingml/2006/main">
+            <a:srgbClr val="FFFFFF"/>
+          </a:solidFill>
+          <a:ln xmlns:a="http://schemas.openxmlformats.org/drawingml/2006/main" w="19050">
+            <a:solidFill>
+              <a:srgbClr val="2463A6"/>
+            </a:solidFill>
+          </a:ln>
+        </p:spPr>
+        <p:txBody>
+          <a:bodyPr xmlns:a="http://schemas.openxmlformats.org/drawingml/2006/main" lIns="76200" tIns="38100" rIns="76200" bIns="38100" anchor="ctr">
+            <a:noAutofit/>
+          </a:bodyPr>
+          <a:lstStyle xmlns:a="http://schemas.openxmlformats.org/drawingml/2006/main"/>
+          <a:p xmlns:a="http://schemas.openxmlformats.org/drawingml/2006/main">
+            <a:pPr algn="ctr">
+              <a:defRPr sz="1650" b="1">
+                <a:solidFill>
+                  <a:srgbClr val="2463A6"/>
+                </a:solidFill>
+                <a:latin typeface="Arial"/>
+                <a:ea typeface="Arial"/>
+                <a:cs typeface="Arial"/>
+              </a:defRPr>
+            </a:pPr>
+            <a:r>
+              <a:rPr sz="1650" b="1">
+                <a:solidFill>
+                  <a:srgbClr val="2463A6"/>
+                </a:solidFill>
+                <a:latin typeface="Arial"/>
+                <a:ea typeface="Arial"/>
+                <a:cs typeface="Arial"/>
+              </a:rPr>
+              <a:t>Separate email dispatcher</a:t>
+            </a:r>
+          </a:p>
+          <a:p xmlns:a="http://schemas.openxmlformats.org/drawingml/2006/main">
+            <a:pPr algn="ctr">
+              <a:defRPr sz="1650" b="1">
+                <a:solidFill>
+                  <a:srgbClr val="2463A6"/>
+                </a:solidFill>
+                <a:latin typeface="Arial"/>
+                <a:ea typeface="Arial"/>
+                <a:cs typeface="Arial"/>
+              </a:defRPr>
+            </a:pPr>
+            <a:r>
+              <a:rPr sz="1650" b="1">
+                <a:solidFill>
+                  <a:srgbClr val="2463A6"/>
+                </a:solidFill>
+                <a:latin typeface="Arial"/>
+                <a:ea typeface="Arial"/>
+                <a:cs typeface="Arial"/>
+              </a:rPr>
+              <a:t>SMTP retries and rate cap</a:t>
+            </a:r>
+          </a:p>
+        </p:txBody>
+      </p:sp>
+      <p:sp>
+        <p:nvSpPr>
+          <p:cNvPr id="51" name="notification-inbox">
+            <a:extLst xmlns:a="http://schemas.openxmlformats.org/drawingml/2006/main">
+              <a:ext uri="{FF2B5EF4-FFF2-40B4-BE49-F238E27FC236}">
+                <a16:creationId xmlns:a16="http://schemas.microsoft.com/office/drawing/2014/main" id="{DF51008B-DD10-4A0B-ABEB-9FC4D7831433}"/>
+              </a:ext>
+            </a:extLst>
+          </p:cNvPr>
+          <p:cNvSpPr>
+            <a:spLocks xmlns:a="http://schemas.openxmlformats.org/drawingml/2006/main" noGrp="1"/>
+          </p:cNvSpPr>
+          <p:nvPr/>
+        </p:nvSpPr>
+        <p:spPr>
+          <a:xfrm xmlns:a="http://schemas.openxmlformats.org/drawingml/2006/main">
+            <a:off x="8582025" y="5619750"/>
+            <a:ext cx="2971800" cy="561975"/>
+          </a:xfrm>
+          <a:prstGeom xmlns:a="http://schemas.openxmlformats.org/drawingml/2006/main" prst="rect">
+            <a:avLst/>
+          </a:prstGeom>
+          <a:solidFill xmlns:a="http://schemas.openxmlformats.org/drawingml/2006/main">
+            <a:srgbClr val="FFFFFF"/>
+          </a:solidFill>
+          <a:ln xmlns:a="http://schemas.openxmlformats.org/drawingml/2006/main" w="19050">
+            <a:solidFill>
+              <a:srgbClr val="2463A6"/>
+            </a:solidFill>
+          </a:ln>
+        </p:spPr>
+        <p:txBody>
+          <a:bodyPr xmlns:a="http://schemas.openxmlformats.org/drawingml/2006/main" lIns="76200" tIns="38100" rIns="76200" bIns="38100" anchor="ctr">
+            <a:noAutofit/>
+          </a:bodyPr>
+          <a:lstStyle xmlns:a="http://schemas.openxmlformats.org/drawingml/2006/main"/>
+          <a:p xmlns:a="http://schemas.openxmlformats.org/drawingml/2006/main">
+            <a:pPr algn="ctr">
+              <a:defRPr sz="1650" b="1">
+                <a:solidFill>
+                  <a:srgbClr val="2463A6"/>
+                </a:solidFill>
+                <a:latin typeface="Arial"/>
+                <a:ea typeface="Arial"/>
+                <a:cs typeface="Arial"/>
+              </a:defRPr>
+            </a:pPr>
+            <a:r>
+              <a:rPr sz="1650" b="1">
+                <a:solidFill>
+                  <a:srgbClr val="2463A6"/>
+                </a:solidFill>
+                <a:latin typeface="Arial"/>
+                <a:ea typeface="Arial"/>
+                <a:cs typeface="Arial"/>
+              </a:rPr>
+              <a:t>Mailpit local inbox</a:t>
+            </a:r>
+          </a:p>
+          <a:p xmlns:a="http://schemas.openxmlformats.org/drawingml/2006/main">
+            <a:pPr algn="ctr">
+              <a:defRPr sz="1650" b="1">
+                <a:solidFill>
+                  <a:srgbClr val="2463A6"/>
+                </a:solidFill>
+                <a:latin typeface="Arial"/>
+                <a:ea typeface="Arial"/>
+                <a:cs typeface="Arial"/>
+              </a:defRPr>
+            </a:pPr>
+            <a:r>
+              <a:rPr sz="1650" b="1">
+                <a:solidFill>
+                  <a:srgbClr val="2463A6"/>
+                </a:solidFill>
+                <a:latin typeface="Arial"/>
+                <a:ea typeface="Arial"/>
+                <a:cs typeface="Arial"/>
+              </a:rPr>
+              <a:t>SMTP by configuration</a:t>
+            </a:r>
+          </a:p>
+        </p:txBody>
+      </p:sp>
+      <p:cxnSp>
+        <p:nvCxnSpPr>
+          <p:cNvPr id="82" name=""/>
+          <p:cNvCxnSpPr>
+            <a:stCxn xmlns:a="http://schemas.openxmlformats.org/drawingml/2006/main" id="49" idx="3"/>
+            <a:endCxn xmlns:a="http://schemas.openxmlformats.org/drawingml/2006/main" id="50" idx="1"/>
+          </p:cNvCxnSpPr>
+          <p:nvPr/>
+        </p:nvCxnSpPr>
+        <p:spPr>
+          <a:xfrm xmlns:a="http://schemas.openxmlformats.org/drawingml/2006/main">
+            <a:off x="3857625" y="5900738"/>
+            <a:ext cx="742950" cy="0"/>
+          </a:xfrm>
+          <a:prstGeom xmlns:a="http://schemas.openxmlformats.org/drawingml/2006/main" prst="straightConnector1">
+            <a:avLst/>
+          </a:prstGeom>
+          <a:ln xmlns:a="http://schemas.openxmlformats.org/drawingml/2006/main" w="19050">
+            <a:solidFill>
+              <a:srgbClr val="2463A6"/>
+            </a:solidFill>
+            <a:tailEnd type="triangle" w="sm" len="sm"/>
+          </a:ln>
+        </p:spPr>
+      </p:cxnSp>
+      <p:cxnSp>
+        <p:nvCxnSpPr>
+          <p:cNvPr id="83" name=""/>
+          <p:cNvCxnSpPr>
+            <a:stCxn xmlns:a="http://schemas.openxmlformats.org/drawingml/2006/main" id="50" idx="3"/>
+            <a:endCxn xmlns:a="http://schemas.openxmlformats.org/drawingml/2006/main" id="51" idx="1"/>
+          </p:cNvCxnSpPr>
+          <p:nvPr/>
+        </p:nvCxnSpPr>
+        <p:spPr>
+          <a:xfrm xmlns:a="http://schemas.openxmlformats.org/drawingml/2006/main">
+            <a:off x="7839075" y="5900738"/>
+            <a:ext cx="742950" cy="0"/>
+          </a:xfrm>
+          <a:prstGeom xmlns:a="http://schemas.openxmlformats.org/drawingml/2006/main" prst="straightConnector1">
+            <a:avLst/>
+          </a:prstGeom>
+          <a:ln xmlns:a="http://schemas.openxmlformats.org/drawingml/2006/main" w="19050">
+            <a:solidFill>
+              <a:srgbClr val="2463A6"/>
+            </a:solidFill>
+            <a:tailEnd type="triangle" w="sm" len="sm"/>
+          </a:ln>
+        </p:spPr>
+      </p:cxnSp>
     </p:spTree>
     <p:extLst>
       <p:ext uri="{BB962C8B-B14F-4D97-AF65-F5344CB8AC3E}">
@@ -8709,6 +9228,7 @@
           <a:lstStyle xmlns:a="http://schemas.openxmlformats.org/drawingml/2006/main"/>
           <a:p xmlns:a="http://schemas.openxmlformats.org/drawingml/2006/main">
             <a:pPr algn="l">
+              <a:buNone/>
               <a:defRPr sz="3300" b="1">
                 <a:solidFill>
                   <a:srgbClr val="142D4E"/>
@@ -8766,6 +9286,7 @@
           <a:lstStyle xmlns:a="http://schemas.openxmlformats.org/drawingml/2006/main"/>
           <a:p xmlns:a="http://schemas.openxmlformats.org/drawingml/2006/main">
             <a:pPr algn="l">
+              <a:buNone/>
               <a:defRPr sz="1275" b="0">
                 <a:solidFill>
                   <a:srgbClr val="5E6A78"/>
@@ -8823,6 +9344,7 @@
           <a:lstStyle xmlns:a="http://schemas.openxmlformats.org/drawingml/2006/main"/>
           <a:p xmlns:a="http://schemas.openxmlformats.org/drawingml/2006/main">
             <a:pPr algn="r">
+              <a:buNone/>
               <a:defRPr sz="1425" b="0">
                 <a:solidFill>
                   <a:srgbClr val="5E6A78"/>
@@ -8880,6 +9402,7 @@
           <a:lstStyle xmlns:a="http://schemas.openxmlformats.org/drawingml/2006/main"/>
           <a:p xmlns:a="http://schemas.openxmlformats.org/drawingml/2006/main">
             <a:pPr algn="l">
+              <a:buNone/>
               <a:defRPr sz="2475" b="1">
                 <a:solidFill>
                   <a:srgbClr val="2463A6"/>
@@ -8937,6 +9460,7 @@
           <a:lstStyle xmlns:a="http://schemas.openxmlformats.org/drawingml/2006/main"/>
           <a:p xmlns:a="http://schemas.openxmlformats.org/drawingml/2006/main">
             <a:pPr algn="l">
+              <a:buNone/>
               <a:defRPr sz="1875" b="1">
                 <a:solidFill>
                   <a:srgbClr val="142D4E"/>
@@ -8994,6 +9518,7 @@
           <a:lstStyle xmlns:a="http://schemas.openxmlformats.org/drawingml/2006/main"/>
           <a:p xmlns:a="http://schemas.openxmlformats.org/drawingml/2006/main">
             <a:pPr algn="l">
+              <a:buNone/>
               <a:defRPr sz="1725" b="0">
                 <a:solidFill>
                   <a:srgbClr val="26364B"/>
@@ -9082,6 +9607,7 @@
           <a:lstStyle xmlns:a="http://schemas.openxmlformats.org/drawingml/2006/main"/>
           <a:p xmlns:a="http://schemas.openxmlformats.org/drawingml/2006/main">
             <a:pPr algn="l">
+              <a:buNone/>
               <a:defRPr sz="2475" b="1">
                 <a:solidFill>
                   <a:srgbClr val="2463A6"/>
@@ -9139,6 +9665,7 @@
           <a:lstStyle xmlns:a="http://schemas.openxmlformats.org/drawingml/2006/main"/>
           <a:p xmlns:a="http://schemas.openxmlformats.org/drawingml/2006/main">
             <a:pPr algn="l">
+              <a:buNone/>
               <a:defRPr sz="1875" b="1">
                 <a:solidFill>
                   <a:srgbClr val="142D4E"/>
@@ -9196,6 +9723,7 @@
           <a:lstStyle xmlns:a="http://schemas.openxmlformats.org/drawingml/2006/main"/>
           <a:p xmlns:a="http://schemas.openxmlformats.org/drawingml/2006/main">
             <a:pPr algn="l">
+              <a:buNone/>
               <a:defRPr sz="1725" b="0">
                 <a:solidFill>
                   <a:srgbClr val="26364B"/>
@@ -9284,6 +9812,7 @@
           <a:lstStyle xmlns:a="http://schemas.openxmlformats.org/drawingml/2006/main"/>
           <a:p xmlns:a="http://schemas.openxmlformats.org/drawingml/2006/main">
             <a:pPr algn="l">
+              <a:buNone/>
               <a:defRPr sz="2475" b="1">
                 <a:solidFill>
                   <a:srgbClr val="2463A6"/>
@@ -9341,6 +9870,7 @@
           <a:lstStyle xmlns:a="http://schemas.openxmlformats.org/drawingml/2006/main"/>
           <a:p xmlns:a="http://schemas.openxmlformats.org/drawingml/2006/main">
             <a:pPr algn="l">
+              <a:buNone/>
               <a:defRPr sz="1875" b="1">
                 <a:solidFill>
                   <a:srgbClr val="142D4E"/>
@@ -9398,6 +9928,7 @@
           <a:lstStyle xmlns:a="http://schemas.openxmlformats.org/drawingml/2006/main"/>
           <a:p xmlns:a="http://schemas.openxmlformats.org/drawingml/2006/main">
             <a:pPr algn="l">
+              <a:buNone/>
               <a:defRPr sz="1725" b="0">
                 <a:solidFill>
                   <a:srgbClr val="26364B"/>
@@ -9486,6 +10017,7 @@
           <a:lstStyle xmlns:a="http://schemas.openxmlformats.org/drawingml/2006/main"/>
           <a:p xmlns:a="http://schemas.openxmlformats.org/drawingml/2006/main">
             <a:pPr algn="l">
+              <a:buNone/>
               <a:defRPr sz="2475" b="1">
                 <a:solidFill>
                   <a:srgbClr val="2463A6"/>
@@ -9543,6 +10075,7 @@
           <a:lstStyle xmlns:a="http://schemas.openxmlformats.org/drawingml/2006/main"/>
           <a:p xmlns:a="http://schemas.openxmlformats.org/drawingml/2006/main">
             <a:pPr algn="l">
+              <a:buNone/>
               <a:defRPr sz="1875" b="1">
                 <a:solidFill>
                   <a:srgbClr val="142D4E"/>
@@ -9600,6 +10133,7 @@
           <a:lstStyle xmlns:a="http://schemas.openxmlformats.org/drawingml/2006/main"/>
           <a:p xmlns:a="http://schemas.openxmlformats.org/drawingml/2006/main">
             <a:pPr algn="l">
+              <a:buNone/>
               <a:defRPr sz="1725" b="0">
                 <a:solidFill>
                   <a:srgbClr val="26364B"/>
@@ -9688,6 +10222,7 @@
           <a:lstStyle xmlns:a="http://schemas.openxmlformats.org/drawingml/2006/main"/>
           <a:p xmlns:a="http://schemas.openxmlformats.org/drawingml/2006/main">
             <a:pPr algn="l">
+              <a:buNone/>
               <a:defRPr sz="2475" b="1">
                 <a:solidFill>
                   <a:srgbClr val="2463A6"/>
@@ -9745,6 +10280,7 @@
           <a:lstStyle xmlns:a="http://schemas.openxmlformats.org/drawingml/2006/main"/>
           <a:p xmlns:a="http://schemas.openxmlformats.org/drawingml/2006/main">
             <a:pPr algn="l">
+              <a:buNone/>
               <a:defRPr sz="1875" b="1">
                 <a:solidFill>
                   <a:srgbClr val="142D4E"/>
@@ -9802,6 +10338,7 @@
           <a:lstStyle xmlns:a="http://schemas.openxmlformats.org/drawingml/2006/main"/>
           <a:p xmlns:a="http://schemas.openxmlformats.org/drawingml/2006/main">
             <a:pPr algn="l">
+              <a:buNone/>
               <a:defRPr sz="1725" b="0">
                 <a:solidFill>
                   <a:srgbClr val="26364B"/>
@@ -9890,6 +10427,7 @@
           <a:lstStyle xmlns:a="http://schemas.openxmlformats.org/drawingml/2006/main"/>
           <a:p xmlns:a="http://schemas.openxmlformats.org/drawingml/2006/main">
             <a:pPr algn="l">
+              <a:buNone/>
               <a:defRPr sz="2475" b="1">
                 <a:solidFill>
                   <a:srgbClr val="2463A6"/>
@@ -9947,6 +10485,7 @@
           <a:lstStyle xmlns:a="http://schemas.openxmlformats.org/drawingml/2006/main"/>
           <a:p xmlns:a="http://schemas.openxmlformats.org/drawingml/2006/main">
             <a:pPr algn="l">
+              <a:buNone/>
               <a:defRPr sz="1875" b="1">
                 <a:solidFill>
                   <a:srgbClr val="142D4E"/>
@@ -10004,6 +10543,7 @@
           <a:lstStyle xmlns:a="http://schemas.openxmlformats.org/drawingml/2006/main"/>
           <a:p xmlns:a="http://schemas.openxmlformats.org/drawingml/2006/main">
             <a:pPr algn="l">
+              <a:buNone/>
               <a:defRPr sz="1725" b="0">
                 <a:solidFill>
                   <a:srgbClr val="26364B"/>
@@ -10090,6 +10630,7 @@
           <a:lstStyle xmlns:a="http://schemas.openxmlformats.org/drawingml/2006/main"/>
           <a:p xmlns:a="http://schemas.openxmlformats.org/drawingml/2006/main">
             <a:pPr algn="l">
+              <a:buNone/>
               <a:defRPr sz="3300" b="1">
                 <a:solidFill>
                   <a:srgbClr val="142D4E"/>
@@ -10147,6 +10688,7 @@
           <a:lstStyle xmlns:a="http://schemas.openxmlformats.org/drawingml/2006/main"/>
           <a:p xmlns:a="http://schemas.openxmlformats.org/drawingml/2006/main">
             <a:pPr algn="l">
+              <a:buNone/>
               <a:defRPr sz="1800" b="0">
                 <a:solidFill>
                   <a:srgbClr val="5E6A78"/>
@@ -10204,6 +10746,7 @@
           <a:lstStyle xmlns:a="http://schemas.openxmlformats.org/drawingml/2006/main"/>
           <a:p xmlns:a="http://schemas.openxmlformats.org/drawingml/2006/main">
             <a:pPr algn="l">
+              <a:buNone/>
               <a:defRPr sz="1275" b="0">
                 <a:solidFill>
                   <a:srgbClr val="5E6A78"/>
@@ -10261,6 +10804,7 @@
           <a:lstStyle xmlns:a="http://schemas.openxmlformats.org/drawingml/2006/main"/>
           <a:p xmlns:a="http://schemas.openxmlformats.org/drawingml/2006/main">
             <a:pPr algn="r">
+              <a:buNone/>
               <a:defRPr sz="1425" b="0">
                 <a:solidFill>
                   <a:srgbClr val="5E6A78"/>
@@ -10286,7 +10830,7 @@
       </p:sp>
       <p:graphicFrame>
         <p:nvGraphicFramePr>
-          <p:cNvPr id="12" name=""/>
+          <p:cNvPr id="15" name=""/>
           <p:cNvGraphicFramePr/>
           <p:nvPr/>
         </p:nvGraphicFramePr>
@@ -10522,7 +11066,7 @@
       </p:graphicFrame>
       <p:graphicFrame>
         <p:nvGraphicFramePr>
-          <p:cNvPr id="13" name=""/>
+          <p:cNvPr id="16" name=""/>
           <p:cNvGraphicFramePr/>
           <p:nvPr/>
         </p:nvGraphicFramePr>
@@ -10792,6 +11336,7 @@
           <a:lstStyle xmlns:a="http://schemas.openxmlformats.org/drawingml/2006/main"/>
           <a:p xmlns:a="http://schemas.openxmlformats.org/drawingml/2006/main">
             <a:pPr algn="l">
+              <a:buNone/>
               <a:defRPr sz="1725" b="0">
                 <a:solidFill>
                   <a:srgbClr val="5E6A78"/>
@@ -10878,6 +11423,7 @@
           <a:lstStyle xmlns:a="http://schemas.openxmlformats.org/drawingml/2006/main"/>
           <a:p xmlns:a="http://schemas.openxmlformats.org/drawingml/2006/main">
             <a:pPr algn="l">
+              <a:buNone/>
               <a:defRPr sz="3300" b="1">
                 <a:solidFill>
                   <a:srgbClr val="142D4E"/>
@@ -10935,6 +11481,7 @@
           <a:lstStyle xmlns:a="http://schemas.openxmlformats.org/drawingml/2006/main"/>
           <a:p xmlns:a="http://schemas.openxmlformats.org/drawingml/2006/main">
             <a:pPr algn="l">
+              <a:buNone/>
               <a:defRPr sz="1275" b="0">
                 <a:solidFill>
                   <a:srgbClr val="5E6A78"/>
@@ -10992,6 +11539,7 @@
           <a:lstStyle xmlns:a="http://schemas.openxmlformats.org/drawingml/2006/main"/>
           <a:p xmlns:a="http://schemas.openxmlformats.org/drawingml/2006/main">
             <a:pPr algn="r">
+              <a:buNone/>
               <a:defRPr sz="1425" b="0">
                 <a:solidFill>
                   <a:srgbClr val="5E6A78"/>
@@ -11017,7 +11565,7 @@
       </p:sp>
       <p:graphicFrame>
         <p:nvGraphicFramePr>
-          <p:cNvPr id="10" name=""/>
+          <p:cNvPr id="12" name=""/>
           <p:cNvGraphicFramePr/>
           <p:nvPr/>
         </p:nvGraphicFramePr>
@@ -11472,6 +12020,7 @@
           <a:lstStyle xmlns:a="http://schemas.openxmlformats.org/drawingml/2006/main"/>
           <a:p xmlns:a="http://schemas.openxmlformats.org/drawingml/2006/main">
             <a:pPr algn="l">
+              <a:buNone/>
               <a:defRPr sz="2025" b="1">
                 <a:solidFill>
                   <a:srgbClr val="2463A6"/>
@@ -11529,6 +12078,7 @@
           <a:lstStyle xmlns:a="http://schemas.openxmlformats.org/drawingml/2006/main"/>
           <a:p xmlns:a="http://schemas.openxmlformats.org/drawingml/2006/main">
             <a:pPr algn="l">
+              <a:buNone/>
               <a:defRPr sz="1875" b="0">
                 <a:solidFill>
                   <a:srgbClr val="5E6A78"/>
@@ -11615,6 +12165,7 @@
           <a:lstStyle xmlns:a="http://schemas.openxmlformats.org/drawingml/2006/main"/>
           <a:p xmlns:a="http://schemas.openxmlformats.org/drawingml/2006/main">
             <a:pPr algn="l">
+              <a:buNone/>
               <a:defRPr sz="3300" b="1">
                 <a:solidFill>
                   <a:srgbClr val="142D4E"/>
@@ -11672,6 +12223,7 @@
           <a:lstStyle xmlns:a="http://schemas.openxmlformats.org/drawingml/2006/main"/>
           <a:p xmlns:a="http://schemas.openxmlformats.org/drawingml/2006/main">
             <a:pPr algn="l">
+              <a:buNone/>
               <a:defRPr sz="1800" b="0">
                 <a:solidFill>
                   <a:srgbClr val="5E6A78"/>
@@ -11729,6 +12281,7 @@
           <a:lstStyle xmlns:a="http://schemas.openxmlformats.org/drawingml/2006/main"/>
           <a:p xmlns:a="http://schemas.openxmlformats.org/drawingml/2006/main">
             <a:pPr algn="l">
+              <a:buNone/>
               <a:defRPr sz="1275" b="0">
                 <a:solidFill>
                   <a:srgbClr val="5E6A78"/>
@@ -11786,6 +12339,7 @@
           <a:lstStyle xmlns:a="http://schemas.openxmlformats.org/drawingml/2006/main"/>
           <a:p xmlns:a="http://schemas.openxmlformats.org/drawingml/2006/main">
             <a:pPr algn="r">
+              <a:buNone/>
               <a:defRPr sz="1425" b="0">
                 <a:solidFill>
                   <a:srgbClr val="5E6A78"/>
@@ -11848,6 +12402,7 @@
           <a:lstStyle xmlns:a="http://schemas.openxmlformats.org/drawingml/2006/main"/>
           <a:p xmlns:a="http://schemas.openxmlformats.org/drawingml/2006/main">
             <a:pPr algn="ctr">
+              <a:buNone/>
               <a:defRPr sz="1800" b="1">
                 <a:solidFill>
                   <a:srgbClr val="2463A6"/>
@@ -11871,6 +12426,7 @@
           </a:p>
           <a:p xmlns:a="http://schemas.openxmlformats.org/drawingml/2006/main">
             <a:pPr algn="ctr">
+              <a:buNone/>
               <a:defRPr sz="1800" b="1">
                 <a:solidFill>
                   <a:srgbClr val="2463A6"/>
@@ -11933,6 +12489,7 @@
           <a:lstStyle xmlns:a="http://schemas.openxmlformats.org/drawingml/2006/main"/>
           <a:p xmlns:a="http://schemas.openxmlformats.org/drawingml/2006/main">
             <a:pPr algn="ctr">
+              <a:buNone/>
               <a:defRPr sz="1800" b="1">
                 <a:solidFill>
                   <a:srgbClr val="2463A6"/>
@@ -11956,6 +12513,7 @@
           </a:p>
           <a:p xmlns:a="http://schemas.openxmlformats.org/drawingml/2006/main">
             <a:pPr algn="ctr">
+              <a:buNone/>
               <a:defRPr sz="1800" b="1">
                 <a:solidFill>
                   <a:srgbClr val="2463A6"/>
@@ -12018,6 +12576,7 @@
           <a:lstStyle xmlns:a="http://schemas.openxmlformats.org/drawingml/2006/main"/>
           <a:p xmlns:a="http://schemas.openxmlformats.org/drawingml/2006/main">
             <a:pPr algn="ctr">
+              <a:buNone/>
               <a:defRPr sz="1800" b="1">
                 <a:solidFill>
                   <a:srgbClr val="2463A6"/>
@@ -12041,6 +12600,7 @@
           </a:p>
           <a:p xmlns:a="http://schemas.openxmlformats.org/drawingml/2006/main">
             <a:pPr algn="ctr">
+              <a:buNone/>
               <a:defRPr sz="1800" b="1">
                 <a:solidFill>
                   <a:srgbClr val="2463A6"/>
@@ -12066,7 +12626,7 @@
       </p:sp>
       <p:cxnSp>
         <p:nvCxnSpPr>
-          <p:cNvPr id="21" name=""/>
+          <p:cNvPr id="30" name=""/>
           <p:cNvCxnSpPr>
             <a:stCxn xmlns:a="http://schemas.openxmlformats.org/drawingml/2006/main" id="5" idx="3"/>
             <a:endCxn xmlns:a="http://schemas.openxmlformats.org/drawingml/2006/main" id="6" idx="1"/>
@@ -12092,7 +12652,7 @@
       </p:cxnSp>
       <p:cxnSp>
         <p:nvCxnSpPr>
-          <p:cNvPr id="22" name=""/>
+          <p:cNvPr id="31" name=""/>
           <p:cNvCxnSpPr>
             <a:stCxn xmlns:a="http://schemas.openxmlformats.org/drawingml/2006/main" id="6" idx="3"/>
             <a:endCxn xmlns:a="http://schemas.openxmlformats.org/drawingml/2006/main" id="7" idx="1"/>
@@ -12150,6 +12710,7 @@
           <a:lstStyle xmlns:a="http://schemas.openxmlformats.org/drawingml/2006/main"/>
           <a:p xmlns:a="http://schemas.openxmlformats.org/drawingml/2006/main">
             <a:pPr algn="l">
+              <a:buNone/>
               <a:defRPr sz="1800" b="0">
                 <a:solidFill>
                   <a:srgbClr val="B43138"/>
@@ -12207,6 +12768,7 @@
           <a:lstStyle xmlns:a="http://schemas.openxmlformats.org/drawingml/2006/main"/>
           <a:p xmlns:a="http://schemas.openxmlformats.org/drawingml/2006/main">
             <a:pPr algn="l">
+              <a:buNone/>
               <a:defRPr sz="1875" b="1">
                 <a:solidFill>
                   <a:srgbClr val="B43138"/>
@@ -12264,6 +12826,7 @@
           <a:lstStyle xmlns:a="http://schemas.openxmlformats.org/drawingml/2006/main"/>
           <a:p xmlns:a="http://schemas.openxmlformats.org/drawingml/2006/main">
             <a:pPr algn="l">
+              <a:buNone/>
               <a:defRPr sz="2025" b="0">
                 <a:solidFill>
                   <a:srgbClr val="B43138"/>
@@ -12287,6 +12850,7 @@
           </a:p>
           <a:p xmlns:a="http://schemas.openxmlformats.org/drawingml/2006/main">
             <a:pPr algn="l">
+              <a:buNone/>
               <a:defRPr sz="2025" b="0">
                 <a:solidFill>
                   <a:srgbClr val="B43138"/>
@@ -12344,6 +12908,7 @@
           <a:lstStyle xmlns:a="http://schemas.openxmlformats.org/drawingml/2006/main"/>
           <a:p xmlns:a="http://schemas.openxmlformats.org/drawingml/2006/main">
             <a:pPr algn="l">
+              <a:buNone/>
               <a:defRPr sz="2175" b="0">
                 <a:solidFill>
                   <a:srgbClr val="142D4E"/>
@@ -12367,6 +12932,7 @@
           </a:p>
           <a:p xmlns:a="http://schemas.openxmlformats.org/drawingml/2006/main">
             <a:pPr algn="l">
+              <a:buNone/>
               <a:defRPr sz="2175" b="0">
                 <a:solidFill>
                   <a:srgbClr val="142D4E"/>
@@ -12453,6 +13019,7 @@
           <a:lstStyle xmlns:a="http://schemas.openxmlformats.org/drawingml/2006/main"/>
           <a:p xmlns:a="http://schemas.openxmlformats.org/drawingml/2006/main">
             <a:pPr algn="l">
+              <a:buNone/>
               <a:defRPr sz="3300" b="1">
                 <a:solidFill>
                   <a:srgbClr val="142D4E"/>
@@ -12510,6 +13077,7 @@
           <a:lstStyle xmlns:a="http://schemas.openxmlformats.org/drawingml/2006/main"/>
           <a:p xmlns:a="http://schemas.openxmlformats.org/drawingml/2006/main">
             <a:pPr algn="l">
+              <a:buNone/>
               <a:defRPr sz="1275" b="0">
                 <a:solidFill>
                   <a:srgbClr val="5E6A78"/>
@@ -12567,6 +13135,7 @@
           <a:lstStyle xmlns:a="http://schemas.openxmlformats.org/drawingml/2006/main"/>
           <a:p xmlns:a="http://schemas.openxmlformats.org/drawingml/2006/main">
             <a:pPr algn="r">
+              <a:buNone/>
               <a:defRPr sz="1425" b="0">
                 <a:solidFill>
                   <a:srgbClr val="5E6A78"/>
@@ -12624,6 +13193,7 @@
           <a:lstStyle xmlns:a="http://schemas.openxmlformats.org/drawingml/2006/main"/>
           <a:p xmlns:a="http://schemas.openxmlformats.org/drawingml/2006/main">
             <a:pPr algn="l">
+              <a:buNone/>
               <a:defRPr sz="2175" b="1">
                 <a:solidFill>
                   <a:srgbClr val="142D4E"/>
@@ -12686,6 +13256,7 @@
           <a:lstStyle xmlns:a="http://schemas.openxmlformats.org/drawingml/2006/main"/>
           <a:p xmlns:a="http://schemas.openxmlformats.org/drawingml/2006/main">
             <a:pPr algn="ctr">
+              <a:buNone/>
               <a:defRPr sz="1800" b="1">
                 <a:solidFill>
                   <a:srgbClr val="2463A6"/>
@@ -12709,6 +13280,7 @@
           </a:p>
           <a:p xmlns:a="http://schemas.openxmlformats.org/drawingml/2006/main">
             <a:pPr algn="ctr">
+              <a:buNone/>
               <a:defRPr sz="1800" b="1">
                 <a:solidFill>
                   <a:srgbClr val="2463A6"/>
@@ -12771,6 +13343,7 @@
           <a:lstStyle xmlns:a="http://schemas.openxmlformats.org/drawingml/2006/main"/>
           <a:p xmlns:a="http://schemas.openxmlformats.org/drawingml/2006/main">
             <a:pPr algn="ctr">
+              <a:buNone/>
               <a:defRPr sz="1800" b="1">
                 <a:solidFill>
                   <a:srgbClr val="2463A6"/>
@@ -12794,6 +13367,7 @@
           </a:p>
           <a:p xmlns:a="http://schemas.openxmlformats.org/drawingml/2006/main">
             <a:pPr algn="ctr">
+              <a:buNone/>
               <a:defRPr sz="1800" b="1">
                 <a:solidFill>
                   <a:srgbClr val="2463A6"/>
@@ -12856,6 +13430,7 @@
           <a:lstStyle xmlns:a="http://schemas.openxmlformats.org/drawingml/2006/main"/>
           <a:p xmlns:a="http://schemas.openxmlformats.org/drawingml/2006/main">
             <a:pPr algn="ctr">
+              <a:buNone/>
               <a:defRPr sz="1800" b="1">
                 <a:solidFill>
                   <a:srgbClr val="2463A6"/>
@@ -12879,6 +13454,7 @@
           </a:p>
           <a:p xmlns:a="http://schemas.openxmlformats.org/drawingml/2006/main">
             <a:pPr algn="ctr">
+              <a:buNone/>
               <a:defRPr sz="1800" b="1">
                 <a:solidFill>
                   <a:srgbClr val="2463A6"/>
@@ -12904,7 +13480,7 @@
       </p:sp>
       <p:cxnSp>
         <p:nvCxnSpPr>
-          <p:cNvPr id="24" name=""/>
+          <p:cNvPr id="39" name=""/>
           <p:cNvCxnSpPr>
             <a:stCxn xmlns:a="http://schemas.openxmlformats.org/drawingml/2006/main" id="5" idx="3"/>
             <a:endCxn xmlns:a="http://schemas.openxmlformats.org/drawingml/2006/main" id="6" idx="1"/>
@@ -12930,7 +13506,7 @@
       </p:cxnSp>
       <p:cxnSp>
         <p:nvCxnSpPr>
-          <p:cNvPr id="25" name=""/>
+          <p:cNvPr id="40" name=""/>
           <p:cNvCxnSpPr>
             <a:stCxn xmlns:a="http://schemas.openxmlformats.org/drawingml/2006/main" id="6" idx="3"/>
             <a:endCxn xmlns:a="http://schemas.openxmlformats.org/drawingml/2006/main" id="7" idx="1"/>
@@ -12988,6 +13564,7 @@
           <a:lstStyle xmlns:a="http://schemas.openxmlformats.org/drawingml/2006/main"/>
           <a:p xmlns:a="http://schemas.openxmlformats.org/drawingml/2006/main">
             <a:pPr algn="l">
+              <a:buNone/>
               <a:defRPr sz="2175" b="1">
                 <a:solidFill>
                   <a:srgbClr val="142D4E"/>
@@ -13050,6 +13627,7 @@
           <a:lstStyle xmlns:a="http://schemas.openxmlformats.org/drawingml/2006/main"/>
           <a:p xmlns:a="http://schemas.openxmlformats.org/drawingml/2006/main">
             <a:pPr algn="ctr">
+              <a:buNone/>
               <a:defRPr sz="1800" b="1">
                 <a:solidFill>
                   <a:srgbClr val="2463A6"/>
@@ -13073,6 +13651,7 @@
           </a:p>
           <a:p xmlns:a="http://schemas.openxmlformats.org/drawingml/2006/main">
             <a:pPr algn="ctr">
+              <a:buNone/>
               <a:defRPr sz="1800" b="1">
                 <a:solidFill>
                   <a:srgbClr val="2463A6"/>
@@ -13135,6 +13714,7 @@
           <a:lstStyle xmlns:a="http://schemas.openxmlformats.org/drawingml/2006/main"/>
           <a:p xmlns:a="http://schemas.openxmlformats.org/drawingml/2006/main">
             <a:pPr algn="ctr">
+              <a:buNone/>
               <a:defRPr sz="1800" b="1">
                 <a:solidFill>
                   <a:srgbClr val="2463A6"/>
@@ -13158,6 +13738,7 @@
           </a:p>
           <a:p xmlns:a="http://schemas.openxmlformats.org/drawingml/2006/main">
             <a:pPr algn="ctr">
+              <a:buNone/>
               <a:defRPr sz="1800" b="1">
                 <a:solidFill>
                   <a:srgbClr val="2463A6"/>
@@ -13220,6 +13801,7 @@
           <a:lstStyle xmlns:a="http://schemas.openxmlformats.org/drawingml/2006/main"/>
           <a:p xmlns:a="http://schemas.openxmlformats.org/drawingml/2006/main">
             <a:pPr algn="ctr">
+              <a:buNone/>
               <a:defRPr sz="1800" b="1">
                 <a:solidFill>
                   <a:srgbClr val="2463A6"/>
@@ -13243,6 +13825,7 @@
           </a:p>
           <a:p xmlns:a="http://schemas.openxmlformats.org/drawingml/2006/main">
             <a:pPr algn="ctr">
+              <a:buNone/>
               <a:defRPr sz="1800" b="1">
                 <a:solidFill>
                   <a:srgbClr val="2463A6"/>
@@ -13268,7 +13851,7 @@
       </p:sp>
       <p:cxnSp>
         <p:nvCxnSpPr>
-          <p:cNvPr id="30" name=""/>
+          <p:cNvPr id="45" name=""/>
           <p:cNvCxnSpPr>
             <a:stCxn xmlns:a="http://schemas.openxmlformats.org/drawingml/2006/main" id="11" idx="3"/>
             <a:endCxn xmlns:a="http://schemas.openxmlformats.org/drawingml/2006/main" id="12" idx="1"/>
@@ -13294,7 +13877,7 @@
       </p:cxnSp>
       <p:cxnSp>
         <p:nvCxnSpPr>
-          <p:cNvPr id="31" name=""/>
+          <p:cNvPr id="46" name=""/>
           <p:cNvCxnSpPr>
             <a:stCxn xmlns:a="http://schemas.openxmlformats.org/drawingml/2006/main" id="12" idx="3"/>
             <a:endCxn xmlns:a="http://schemas.openxmlformats.org/drawingml/2006/main" id="13" idx="1"/>
@@ -13352,6 +13935,7 @@
           <a:lstStyle xmlns:a="http://schemas.openxmlformats.org/drawingml/2006/main"/>
           <a:p xmlns:a="http://schemas.openxmlformats.org/drawingml/2006/main">
             <a:pPr algn="l">
+              <a:buNone/>
               <a:defRPr sz="1800" b="0">
                 <a:solidFill>
                   <a:srgbClr val="5E6A78"/>
@@ -13375,6 +13959,7 @@
           </a:p>
           <a:p xmlns:a="http://schemas.openxmlformats.org/drawingml/2006/main">
             <a:pPr algn="l">
+              <a:buNone/>
               <a:defRPr sz="1800" b="0">
                 <a:solidFill>
                   <a:srgbClr val="5E6A78"/>
@@ -13461,6 +14046,7 @@
           <a:lstStyle xmlns:a="http://schemas.openxmlformats.org/drawingml/2006/main"/>
           <a:p xmlns:a="http://schemas.openxmlformats.org/drawingml/2006/main">
             <a:pPr algn="l">
+              <a:buNone/>
               <a:defRPr sz="3300" b="1">
                 <a:solidFill>
                   <a:srgbClr val="142D4E"/>
@@ -13518,6 +14104,7 @@
           <a:lstStyle xmlns:a="http://schemas.openxmlformats.org/drawingml/2006/main"/>
           <a:p xmlns:a="http://schemas.openxmlformats.org/drawingml/2006/main">
             <a:pPr algn="l">
+              <a:buNone/>
               <a:defRPr sz="1275" b="0">
                 <a:solidFill>
                   <a:srgbClr val="5E6A78"/>
@@ -13575,6 +14162,7 @@
           <a:lstStyle xmlns:a="http://schemas.openxmlformats.org/drawingml/2006/main"/>
           <a:p xmlns:a="http://schemas.openxmlformats.org/drawingml/2006/main">
             <a:pPr algn="r">
+              <a:buNone/>
               <a:defRPr sz="1425" b="0">
                 <a:solidFill>
                   <a:srgbClr val="5E6A78"/>
@@ -13600,7 +14188,7 @@
       </p:sp>
       <p:graphicFrame>
         <p:nvGraphicFramePr>
-          <p:cNvPr id="9" name=""/>
+          <p:cNvPr id="11" name=""/>
           <p:cNvGraphicFramePr/>
           <p:nvPr/>
         </p:nvGraphicFramePr>
@@ -13978,6 +14566,7 @@
           <a:lstStyle xmlns:a="http://schemas.openxmlformats.org/drawingml/2006/main"/>
           <a:p xmlns:a="http://schemas.openxmlformats.org/drawingml/2006/main">
             <a:pPr algn="l">
+              <a:buNone/>
               <a:defRPr sz="2100" b="1">
                 <a:solidFill>
                   <a:srgbClr val="2463A6"/>

</xml_diff>